<commit_message>
Finalise viva deck: literature-gap + timeline slides, reorder, speaker notes
Add a literature-gap positioning table and a 16-week project timeline
(Gantt), reorder all 20 slides into a proposal-viva flow (objectives and
literature moved before method; timeline before the close; anticipated
questions as an appendix), add proposal/preliminary framing tags, and
write detailed speaker notes on every slide.

Co-Authored-By: Claude Opus 4.8 <noreply@anthropic.com>
Claude-Session: https://claude.ai/code/session_019JFaBidHiXFF8XfZLCSz2u
</commit_message>
<xml_diff>
--- a/Brain_Tumour_Viva_updated.pptx
+++ b/Brain_Tumour_Viva_updated.pptx
@@ -10,6 +10,8 @@
   <p:sldIdLst>
     <p:sldId id="256" r:id="rId2"/>
     <p:sldId id="257" r:id="rId3"/>
+    <p:sldId id="268" r:id="rId19"/>
+    <p:sldId id="274" r:id="rId25"/>
     <p:sldId id="258" r:id="rId4"/>
     <p:sldId id="259" r:id="rId5"/>
     <p:sldId id="260" r:id="rId6"/>
@@ -19,9 +21,9 @@
     <p:sldId id="264" r:id="rId10"/>
     <p:sldId id="265" r:id="rId11"/>
     <p:sldId id="266" r:id="rId12"/>
+    <p:sldId id="269" r:id="rId20"/>
+    <p:sldId id="275" r:id="rId26"/>
     <p:sldId id="267" r:id="rId13"/>
-    <p:sldId id="268" r:id="rId19"/>
-    <p:sldId id="269" r:id="rId20"/>
     <p:sldId id="270" r:id="rId21"/>
     <p:sldId id="271" r:id="rId22"/>
     <p:sldId id="272" r:id="rId23"/>
@@ -845,8 +847,7 @@
           <a:lstStyle/>
           <a:p>
             <a:r>
-              <a:rPr lang="en-US" dirty="0"/>
-              <a:t>Good morning. My name is Shehan Kavishka. My research is about classifying brain tumours from MRI scans. But I want to start with the real problem, not the technology. When a brain MRI comes in, a radiologist has to decide: is this a glioma, a meningioma, a pituitary tumour, or no tumour at all? That decision changes the entire treatment plan. It's slow, it depends on one person's eye, and mistakes are costly. My project asks: can we build an AI system that is not just accurate, but also honest about when it isn't sure?</a:t>
+              <a:t>Open confidently and slowly. Say: Good morning, I'm Shehan Kavishka, ID E187041. My research is a comparative framework for classifying brain tumours from MRI. I want to start not with the technology but with the clinical problem, because that motivates every design choice. This is my proposal defence - I've already built a working prototype, so the results I show are preliminary evidence the approach is feasible, not final claims. Hold ~20 seconds, make eye contact, then move on.</a:t>
             </a:r>
           </a:p>
         </p:txBody>
@@ -932,8 +933,7 @@
           <a:lstStyle/>
           <a:p>
             <a:r>
-              <a:rPr lang="en-US" dirty="0"/>
-              <a:t>All of this lives inside a working web application, because a research result that stays in a notebook helps no one. Live Diagnosis: a clinician uploads an MRI and instantly sees the predicted type, confidence bar, Grad-CAM heatmaps from all three models plus a consensus map, per-model vote breakdown, and the clinical alert if models disagree. Results Gallery: all research figures in one place — accuracy charts, confusion matrices, EAA-IoU analysis. React front-end, FastAPI backend loading all six models and running xai_engine.py, containerised for cloud deployment.</a:t>
+              <a:t>Stress that a result stuck in a notebook helps no one, so I built a working web app with two screens. Live Diagnosis: upload an MRI and instantly see the predicted type, a confidence bar, Grad-CAM heatmaps from all three models plus a consensus map, a per-model vote breakdown so nothing is hidden, and the escalation alert when models disagree. Results Gallery: all accuracy charts, confusion matrices and EAA-IoU analysis in one place - the full evidence trail, transparent. Technically it's a React front-end on a Python backend, containerised for cloud deployment. Every screen carries a disclaimer: research tool, not a replacement for a radiologist. If possible, demo it live for 30 seconds.</a:t>
             </a:r>
           </a:p>
         </p:txBody>
@@ -1019,8 +1019,7 @@
           <a:lstStyle/>
           <a:p>
             <a:r>
-              <a:rPr lang="en-US" dirty="0"/>
-              <a:t>My best single model was the CNN at 94%. Combining six diverse models by voting pushed that to 98.2%. But accuracy is only half the story — the real contribution is the honesty layer, EAA-IoU, which turns the ensemble from a black box that's confidently wrong into a system that can raise its hand and say this one is ambiguous, get a human. That combination — a confidence-weighted ensemble plus an annotation-free inter-model agreement signal — is, from my literature review, not present in any published brain-tumour paper.</a:t>
+              <a:t>Remind the panel these are PRELIMINARY results proving feasibility, not final claims. Numbers: best single model 94%, and voting across six diverse models pushed that to 98.2 on unseen test data. Say clearly accuracy is only half the story - the real contribution is the honesty layer, EAA-IoU, which turns the ensemble from a black box that's confidently wrong into a system that can raise its hand and say 'this one is ambiguous, get a human.' From my review, the combination - confidence-weighted ensemble plus an annotation-free inter-model agreement signal - isn't present in any published brain-tumour paper.</a:t>
             </a:r>
           </a:p>
         </p:txBody>
@@ -1106,8 +1105,7 @@
           <a:lstStyle/>
           <a:p>
             <a:r>
-              <a:rPr lang="en-US" dirty="0"/>
-              <a:t>So, to close where I started: one model can be confidently wrong. My framework replaces that single opinion with six diverse ones, and then — crucially — checks whether they truly agree, not just on the answer but on the reasoning. That's how you get accuracy and safety in a clinical tool. Thank you. I'm happy to take questions.</a:t>
+              <a:t>Land the close with conviction, no notes-reading. One model can be confidently wrong. My framework replaces that single opinion with six diverse ones, and then - crucially - checks whether they truly agree, not just on the answer but on the reasoning behind it. That is how you get accuracy AND safety in a clinical tool. Pause, then: thank you, I'm happy to take your questions. Then stop talking and let them ask.</a:t>
             </a:r>
           </a:p>
         </p:txBody>
@@ -1141,6 +1139,328 @@
         <p14:creationId xmlns:p14="http://schemas.microsoft.com/office/powerpoint/2010/main" val="1024086991"/>
       </p:ext>
     </p:extLst>
+  </p:cSld>
+  <p:clrMapOvr>
+    <a:masterClrMapping/>
+  </p:clrMapOvr>
+</p:notes>
+</file>
+
+<file path=ppt/notesSlides/notesSlide13.xml><?xml version="1.0" encoding="utf-8"?>
+<p:notes xmlns:a="http://schemas.openxmlformats.org/drawingml/2006/main" xmlns:p="http://schemas.openxmlformats.org/presentationml/2006/main" xmlns:r="http://schemas.openxmlformats.org/officeDocument/2006/relationships">
+  <p:cSld>
+    <p:spTree>
+      <p:nvGrpSpPr>
+        <p:cNvPr id="1" name=""/>
+        <p:cNvGrpSpPr/>
+        <p:nvPr/>
+      </p:nvGrpSpPr>
+      <p:grpSpPr>
+        <a:xfrm>
+          <a:off x="0" y="0"/>
+          <a:ext cx="0" cy="0"/>
+          <a:chOff x="0" y="0"/>
+          <a:chExt cx="0" cy="0"/>
+        </a:xfrm>
+      </p:grpSpPr>
+      <p:sp>
+        <p:nvSpPr>
+          <p:cNvPr id="100" name="Notes Placeholder"/>
+          <p:cNvSpPr>
+            <a:spLocks noGrp="1"/>
+          </p:cNvSpPr>
+          <p:nvPr>
+            <p:ph type="body" idx="1"/>
+          </p:nvPr>
+        </p:nvSpPr>
+        <p:spPr/>
+        <p:txBody>
+          <a:bodyPr/>
+          <a:lstStyle/>
+          <a:p>
+            <a:r>
+              <a:t>Be explicit - proposal panels mark objectives heavily. My primary research question compares fine-tuned feature extractors against standard CNNs and asks what ensemble integration does to accuracy and reliability. On top I added a novel question: does inter-model Grad-CAM agreement (my EAA-IoU score) correlate with misclassification, and can it act as a per-sample clinical uncertainty trigger. These map to six objectives: evaluate CNN feature extraction; assess classical models on CNN features; investigate Xception and InceptionV3 as extractors; evaluate classifiers on pretrained features; measure the ensemble's accuracy gain; and build and validate EAA-IoU. Say the line: every later slide traces back to one of these six.</a:t>
+            </a:r>
+          </a:p>
+        </p:txBody>
+      </p:sp>
+    </p:spTree>
+  </p:cSld>
+  <p:clrMapOvr>
+    <a:masterClrMapping/>
+  </p:clrMapOvr>
+</p:notes>
+</file>
+
+<file path=ppt/notesSlides/notesSlide14.xml><?xml version="1.0" encoding="utf-8"?>
+<p:notes xmlns:a="http://schemas.openxmlformats.org/drawingml/2006/main" xmlns:p="http://schemas.openxmlformats.org/presentationml/2006/main" xmlns:r="http://schemas.openxmlformats.org/officeDocument/2006/relationships">
+  <p:cSld>
+    <p:spTree>
+      <p:nvGrpSpPr>
+        <p:cNvPr id="1" name=""/>
+        <p:cNvGrpSpPr/>
+        <p:nvPr/>
+      </p:nvGrpSpPr>
+      <p:grpSpPr>
+        <a:xfrm>
+          <a:off x="0" y="0"/>
+          <a:ext cx="0" cy="0"/>
+          <a:chOff x="0" y="0"/>
+          <a:chExt cx="0" cy="0"/>
+        </a:xfrm>
+      </p:grpSpPr>
+      <p:sp>
+        <p:nvSpPr>
+          <p:cNvPr id="100" name="Notes Placeholder"/>
+          <p:cNvSpPr>
+            <a:spLocks noGrp="1"/>
+          </p:cNvSpPr>
+          <p:nvPr>
+            <p:ph type="body" idx="1"/>
+          </p:nvPr>
+        </p:nvSpPr>
+        <p:spPr/>
+        <p:txBody>
+          <a:bodyPr/>
+          <a:lstStyle/>
+          <a:p>
+            <a:r>
+              <a:t>This slide justifies why the work is worth doing. I reviewed the closest recent ensemble-plus-explainability brain-tumour papers. They all do soft or majority voting, and most apply Grad-CAM or Grad-CAM++ per model - those two columns are well covered, and I'm honest they're not my novelty. But two columns are empty across the whole literature: fusing heatmaps into one consensus map, and measuring inter-model IoU as an agreement signal. Where IoU is used, it's only against radiologist annotations, not between the models themselves. My row is the only one ticking all five, and the only one in columns four and five. I'm not claiming a new field - I'm identifying one precise, unoccupied gap and filling it. Point at the highlighted bottom row.</a:t>
+            </a:r>
+          </a:p>
+        </p:txBody>
+      </p:sp>
+    </p:spTree>
+  </p:cSld>
+  <p:clrMapOvr>
+    <a:masterClrMapping/>
+  </p:clrMapOvr>
+</p:notes>
+</file>
+
+<file path=ppt/notesSlides/notesSlide15.xml><?xml version="1.0" encoding="utf-8"?>
+<p:notes xmlns:a="http://schemas.openxmlformats.org/drawingml/2006/main" xmlns:p="http://schemas.openxmlformats.org/presentationml/2006/main" xmlns:r="http://schemas.openxmlformats.org/officeDocument/2006/relationships">
+  <p:cSld>
+    <p:spTree>
+      <p:nvGrpSpPr>
+        <p:cNvPr id="1" name=""/>
+        <p:cNvGrpSpPr/>
+        <p:nvPr/>
+      </p:nvGrpSpPr>
+      <p:grpSpPr>
+        <a:xfrm>
+          <a:off x="0" y="0"/>
+          <a:ext cx="0" cy="0"/>
+          <a:chOff x="0" y="0"/>
+          <a:chExt cx="0" cy="0"/>
+        </a:xfrm>
+      </p:grpSpPr>
+      <p:sp>
+        <p:nvSpPr>
+          <p:cNvPr id="100" name="Notes Placeholder"/>
+          <p:cNvSpPr>
+            <a:spLocks noGrp="1"/>
+          </p:cNvSpPr>
+          <p:nvPr>
+            <p:ph type="body" idx="1"/>
+          </p:nvPr>
+        </p:nvSpPr>
+        <p:spPr/>
+        <p:txBody>
+          <a:bodyPr/>
+          <a:lstStyle/>
+          <a:p>
+            <a:r>
+              <a:t>Show rigour and self-awareness - panels reward this more than a flawless story. How I measure: accuracy, precision, recall and F1 per class and weighted; confusion matrices; ROC and PR curves for EAA-IoU as a misclassification detector; all on the held-out 2,063-image test set. Own the known code issues as already fixed: normalisation standardised to /255 in the app; a legacy Random-Forest cell that instantiated a Decision Tree, corrected; label-encoding differences documented. Then the honest limitations: one dataset limits scanner and demographic diversity; the six-model ensemble is compute-heavy; Grad-CAM approximates attention; EAA-IoU is validated as a correlation, not yet a clinical trial. Framing line: owning these openly is deliberate.</a:t>
+            </a:r>
+          </a:p>
+        </p:txBody>
+      </p:sp>
+    </p:spTree>
+  </p:cSld>
+  <p:clrMapOvr>
+    <a:masterClrMapping/>
+  </p:clrMapOvr>
+</p:notes>
+</file>
+
+<file path=ppt/notesSlides/notesSlide16.xml><?xml version="1.0" encoding="utf-8"?>
+<p:notes xmlns:a="http://schemas.openxmlformats.org/drawingml/2006/main" xmlns:p="http://schemas.openxmlformats.org/presentationml/2006/main" xmlns:r="http://schemas.openxmlformats.org/officeDocument/2006/relationships">
+  <p:cSld>
+    <p:spTree>
+      <p:nvGrpSpPr>
+        <p:cNvPr id="1" name=""/>
+        <p:cNvGrpSpPr/>
+        <p:nvPr/>
+      </p:nvGrpSpPr>
+      <p:grpSpPr>
+        <a:xfrm>
+          <a:off x="0" y="0"/>
+          <a:ext cx="0" cy="0"/>
+          <a:chOff x="0" y="0"/>
+          <a:chExt cx="0" cy="0"/>
+        </a:xfrm>
+      </p:grpSpPr>
+      <p:sp>
+        <p:nvSpPr>
+          <p:cNvPr id="100" name="Notes Placeholder"/>
+          <p:cNvSpPr>
+            <a:spLocks noGrp="1"/>
+          </p:cNvSpPr>
+          <p:nvPr>
+            <p:ph type="body" idx="1"/>
+          </p:nvPr>
+        </p:nvSpPr>
+        <p:spPr/>
+        <p:txBody>
+          <a:bodyPr/>
+          <a:lstStyle/>
+          <a:p>
+            <a:r>
+              <a:t>Walk the 16-week plan across six phases. Three weeks of literature review, dataset prep and environment setup. The biggest block - four weeks - is individual model development, the CNN, classical models and fine-tuning the two pretrained networks, because everything builds on that. Three weeks design and optimise the ensemble; two weeks rigorous evaluation on the held-out set; two weeks build the web app; a final two weeks documentation and testing. Note phases overlap slightly - I prototype the web interface early - but the critical path is model development, then ensemble, then evaluation. Keep to about a minute.</a:t>
+            </a:r>
+          </a:p>
+        </p:txBody>
+      </p:sp>
+    </p:spTree>
+  </p:cSld>
+  <p:clrMapOvr>
+    <a:masterClrMapping/>
+  </p:clrMapOvr>
+</p:notes>
+</file>
+
+<file path=ppt/notesSlides/notesSlide17.xml><?xml version="1.0" encoding="utf-8"?>
+<p:notes xmlns:a="http://schemas.openxmlformats.org/drawingml/2006/main" xmlns:p="http://schemas.openxmlformats.org/presentationml/2006/main" xmlns:r="http://schemas.openxmlformats.org/officeDocument/2006/relationships">
+  <p:cSld>
+    <p:spTree>
+      <p:nvGrpSpPr>
+        <p:cNvPr id="1" name=""/>
+        <p:cNvGrpSpPr/>
+        <p:nvPr/>
+      </p:nvGrpSpPr>
+      <p:grpSpPr>
+        <a:xfrm>
+          <a:off x="0" y="0"/>
+          <a:ext cx="0" cy="0"/>
+          <a:chOff x="0" y="0"/>
+          <a:chExt cx="0" cy="0"/>
+        </a:xfrm>
+      </p:grpSpPr>
+      <p:sp>
+        <p:nvSpPr>
+          <p:cNvPr id="100" name="Notes Placeholder"/>
+          <p:cNvSpPr>
+            <a:spLocks noGrp="1"/>
+          </p:cNvSpPr>
+          <p:nvPr>
+            <p:ph type="body" idx="1"/>
+          </p:nvPr>
+        </p:nvSpPr>
+        <p:spPr/>
+        <p:txBody>
+          <a:bodyPr/>
+          <a:lstStyle/>
+          <a:p>
+            <a:r>
+              <a:t>Transition slide only - you normally won't present it. Say: I've prepared answers to the questions I expect, happy to go into any. These three appendix slides are your safety net; glance at them if a question matches, otherwise leave them hidden.</a:t>
+            </a:r>
+          </a:p>
+        </p:txBody>
+      </p:sp>
+    </p:spTree>
+  </p:cSld>
+  <p:clrMapOvr>
+    <a:masterClrMapping/>
+  </p:clrMapOvr>
+</p:notes>
+</file>
+
+<file path=ppt/notesSlides/notesSlide18.xml><?xml version="1.0" encoding="utf-8"?>
+<p:notes xmlns:a="http://schemas.openxmlformats.org/drawingml/2006/main" xmlns:p="http://schemas.openxmlformats.org/presentationml/2006/main" xmlns:r="http://schemas.openxmlformats.org/officeDocument/2006/relationships">
+  <p:cSld>
+    <p:spTree>
+      <p:nvGrpSpPr>
+        <p:cNvPr id="1" name=""/>
+        <p:cNvGrpSpPr/>
+        <p:nvPr/>
+      </p:nvGrpSpPr>
+      <p:grpSpPr>
+        <a:xfrm>
+          <a:off x="0" y="0"/>
+          <a:ext cx="0" cy="0"/>
+          <a:chOff x="0" y="0"/>
+          <a:chExt cx="0" cy="0"/>
+        </a:xfrm>
+      </p:grpSpPr>
+      <p:sp>
+        <p:nvSpPr>
+          <p:cNvPr id="100" name="Notes Placeholder"/>
+          <p:cNvSpPr>
+            <a:spLocks noGrp="1"/>
+          </p:cNvSpPr>
+          <p:nvPr>
+            <p:ph type="body" idx="1"/>
+          </p:nvPr>
+        </p:nvSpPr>
+        <p:spPr/>
+        <p:txBody>
+          <a:bodyPr/>
+          <a:lstStyle/>
+          <a:p>
+            <a:r>
+              <a:t>Backup - don't present unless asked. These four cover the 'why' questions: why an ensemble not one better model (diverse models fail differently; 94 to 98.2 is the proof); why these two backbones (transfer learning plus architectural diversity); what cutting the dense layer means (a second model outputting the 256-feature layer); and why classical ML at all (robust on small data, interpretable, three extra diverse voters). Answer in one or two sentences, then stop.</a:t>
+            </a:r>
+          </a:p>
+        </p:txBody>
+      </p:sp>
+    </p:spTree>
+  </p:cSld>
+  <p:clrMapOvr>
+    <a:masterClrMapping/>
+  </p:clrMapOvr>
+</p:notes>
+</file>
+
+<file path=ppt/notesSlides/notesSlide19.xml><?xml version="1.0" encoding="utf-8"?>
+<p:notes xmlns:a="http://schemas.openxmlformats.org/drawingml/2006/main" xmlns:p="http://schemas.openxmlformats.org/presentationml/2006/main" xmlns:r="http://schemas.openxmlformats.org/officeDocument/2006/relationships">
+  <p:cSld>
+    <p:spTree>
+      <p:nvGrpSpPr>
+        <p:cNvPr id="1" name=""/>
+        <p:cNvGrpSpPr/>
+        <p:nvPr/>
+      </p:nvGrpSpPr>
+      <p:grpSpPr>
+        <a:xfrm>
+          <a:off x="0" y="0"/>
+          <a:ext cx="0" cy="0"/>
+          <a:chOff x="0" y="0"/>
+          <a:chExt cx="0" cy="0"/>
+        </a:xfrm>
+      </p:grpSpPr>
+      <p:sp>
+        <p:nvSpPr>
+          <p:cNvPr id="100" name="Notes Placeholder"/>
+          <p:cNvSpPr>
+            <a:spLocks noGrp="1"/>
+          </p:cNvSpPr>
+          <p:nvPr>
+            <p:ph type="body" idx="1"/>
+          </p:nvPr>
+        </p:nvSpPr>
+        <p:spPr/>
+        <p:txBody>
+          <a:bodyPr/>
+          <a:lstStyle/>
+          <a:p>
+            <a:r>
+              <a:t>Backup for a technical panellist: the 256-feature and input-size rationale; how leakage and overfitting are avoided; the honest admission that confidence-weighted voting is a known, cited method and NOT my novelty; and how EAA-IoU differs from annotation-based XAI. Keep spoken answers short and confident.</a:t>
+            </a:r>
+          </a:p>
+        </p:txBody>
+      </p:sp>
+    </p:spTree>
   </p:cSld>
   <p:clrMapOvr>
     <a:masterClrMapping/>
@@ -1193,8 +1513,7 @@
           <a:lstStyle/>
           <a:p>
             <a:r>
-              <a:rPr lang="en-US" dirty="0"/>
-              <a:t>There are two problems in this field. The first is technical: most published work uses a single model, which inherits one architecture's blind spots. The second is trust: even accurate models are black boxes — they never say how confident the reasoning was, and never flag cases where the model is basically guessing. My framework attacks both: better accuracy through combining models, and a new way to measure uncertainty. Four classes: glioma, meningioma, pituitary, no-tumour.</a:t>
+              <a:t>Tell the story: when a brain MRI arrives, a radiologist must decide glioma, meningioma, pituitary, or no tumour - and that one decision changes the whole treatment plan. It's slow, depends on one expert's eye, and mistakes are costly. Two problems follow: technically, most published work uses ONE model that inherits one architecture's blind spots; and in trust terms, even accurate models are black boxes that never signal when they're unsure. My aim in one line: build a system that is not just accurate, but honest about when it isn't sure. That honesty theme is my thread through the whole talk.</a:t>
             </a:r>
           </a:p>
         </p:txBody>
@@ -1228,6 +1547,52 @@
         <p14:creationId xmlns:p14="http://schemas.microsoft.com/office/powerpoint/2010/main" val="1024086991"/>
       </p:ext>
     </p:extLst>
+  </p:cSld>
+  <p:clrMapOvr>
+    <a:masterClrMapping/>
+  </p:clrMapOvr>
+</p:notes>
+</file>
+
+<file path=ppt/notesSlides/notesSlide20.xml><?xml version="1.0" encoding="utf-8"?>
+<p:notes xmlns:a="http://schemas.openxmlformats.org/drawingml/2006/main" xmlns:p="http://schemas.openxmlformats.org/presentationml/2006/main" xmlns:r="http://schemas.openxmlformats.org/officeDocument/2006/relationships">
+  <p:cSld>
+    <p:spTree>
+      <p:nvGrpSpPr>
+        <p:cNvPr id="1" name=""/>
+        <p:cNvGrpSpPr/>
+        <p:nvPr/>
+      </p:nvGrpSpPr>
+      <p:grpSpPr>
+        <a:xfrm>
+          <a:off x="0" y="0"/>
+          <a:ext cx="0" cy="0"/>
+          <a:chOff x="0" y="0"/>
+          <a:chExt cx="0" cy="0"/>
+        </a:xfrm>
+      </p:grpSpPr>
+      <p:sp>
+        <p:nvSpPr>
+          <p:cNvPr id="100" name="Notes Placeholder"/>
+          <p:cNvSpPr>
+            <a:spLocks noGrp="1"/>
+          </p:cNvSpPr>
+          <p:nvPr>
+            <p:ph type="body" idx="1"/>
+          </p:nvPr>
+        </p:nvSpPr>
+        <p:spPr/>
+        <p:txBody>
+          <a:bodyPr/>
+          <a:lstStyle/>
+          <a:p>
+            <a:r>
+              <a:t>Backup on validity and scope: how I guard against all models being wrong together (designed-in diversity plus the EAA-IoU reasoning check); the normalisation inconsistency, owned and standardised in the app; the single biggest limitation (one dataset, so multi-centre data is the priority); and future work - validating EAA-IoU prospectively, adding stacking and boosting, augmentation, broader datasets. Ending on future work signals maturity.</a:t>
+            </a:r>
+          </a:p>
+        </p:txBody>
+      </p:sp>
+    </p:spTree>
   </p:cSld>
   <p:clrMapOvr>
     <a:masterClrMapping/>
@@ -1280,8 +1645,7 @@
           <a:lstStyle/>
           <a:p>
             <a:r>
-              <a:rPr lang="en-US" dirty="0"/>
-              <a:t>I used the Kaggle Brain Tumour MRI dataset — around 9,000 scans, already split into training and testing folders across four classes. I kept that official split throughout, so every model is judged on unseen images. If asked how I avoid data leakage: feature extraction, model fitting, and hyper-parameter choices all happen on Training only; the Testing folder is touched exactly once.</a:t>
+              <a:t>Keep it tight, ~45 seconds. Kaggle Brain Tumour MRI dataset, ~9,000 scans across four classes, already split into official training and testing folders - I preserve that split throughout. Classes are balanced, ~1,700-1,850 each in training, so the model can't cheat by guessing the majority class. The line examiners want: the testing folder is never touched during training, feature extraction, or model selection - used exactly once, for the final numbers. That kills data-leakage concerns before they're raised.</a:t>
             </a:r>
           </a:p>
         </p:txBody>
@@ -1367,8 +1731,7 @@
           <a:lstStyle/>
           <a:p>
             <a:r>
-              <a:rPr lang="en-US" dirty="0"/>
-              <a:t>Before any model sees an image, every scan goes through the same preprocessing recipe. Read the JPG in colour, resize to a fixed square, fix the BGR-to-RGB colour order for ImageNet compatibility, then normalise. Two input sizes are deliberate: standalone deep models run at 256x256 for maximum detail; feature-extraction backbones run at 128x128 to stay fast and memory-friendly across thousands of images. If pressed on normalisation: standalone models use /255 (range 0-1), ensemble backbones use /255-0.5 (zero-centred) — a documented inconsistency from developing notebooks separately, standardised to /255 in the deployed web app.</a:t>
+              <a:t>Explain fairness comes from identical preprocessing, so I'm comparing models, not preprocessing tricks. Walk the four steps: read the JPG in colour; resize to a fixed square; convert OpenCV's BGR to RGB because ImageNet models expect RGB; convert to float and normalise so pixel values are small and training stable. Then the deliberate two sizes: 256x256 for standalone deep models because one network does the whole job and needs maximum detail, and 128x128 for feature-extraction backbones because I only need a compact vector and smaller keeps thousands of images fast. If pushed on normalisation, admit the /255 vs /255-0.5 difference and note the app standardises to /255 - but don't volunteer it unless asked.</a:t>
             </a:r>
           </a:p>
         </p:txBody>
@@ -1454,8 +1817,7 @@
           <a:lstStyle/>
           <a:p>
             <a:r>
-              <a:rPr lang="en-US" dirty="0"/>
-              <a:t>I started simple, to get a baseline. A custom CNN — four convolution-and-pooling blocks that learn edges, then textures, then tumour-shaped patterns, followed by dense layers for the final four-class decision. Trained from scratch, it reached about 91-94% on the test set. Good, but it's one architecture's opinion, and it started overfitting after about ten epochs. That told me a single model wasn't going to be enough.</a:t>
+              <a:t>Frame as starting simple for a reference point. Four convolution-and-pooling blocks learn edges, then textures, then tumour-shaped patterns; dense layers make the four-class call. From scratch it reached ~91-94%. But two limitations drive the project: it's one architecture's opinion with its own blind spots, and it overfits after ~ten epochs. So a single model, however well tuned, isn't enough - my bridge to transfer learning and an ensemble.</a:t>
             </a:r>
           </a:p>
         </p:txBody>
@@ -1541,8 +1903,7 @@
           <a:lstStyle/>
           <a:p>
             <a:r>
-              <a:rPr lang="en-US" dirty="0"/>
-              <a:t>Why these two, and why pretrained? Transfer learning: Xception and InceptionV3 were trained on ImageNet, already knowing edges, curves, textures and shapes — I freeze those layers and only train a small new head. Diversity: InceptionV3 looks at each region with several filter sizes in parallel; Xception uses depthwise-separable convolutions that separate where a pattern is from its channel. Three architecturally distinct viewpoints mean their mistakes are different — which is what makes the ensemble stronger than any single model. Code: freeze pretrained layers (layer.trainable=False), Flatten, Dense(256, relu) — this is the layer I cut in the next step — Dropout(0.5), Dense(4, softmax).</a:t>
+              <a:t>Favourite question - slow down, give two reasons. First, transfer learning: both were pretrained on 1M+ ImageNet photos, so they already know edges, curves, textures and shapes - and a tumour is still those - so I freeze pretrained layers and train only a small new head on my ~7,000 MRIs. Second, diversity: I picked these two because they think differently. InceptionV3 looks at each region with several filter sizes in parallel, catching fine detail and larger structure at once; Xception uses depthwise-separable convolutions that separate where a pattern is from which channel it's in. Three distinct viewpoints - my CNN, Inception's multi-scale view, Xception's separable view - mean their mistakes differ, and differing mistakes are exactly what makes an ensemble stronger than any single model.</a:t>
             </a:r>
           </a:p>
         </p:txBody>
@@ -1628,8 +1989,7 @@
           <a:lstStyle/>
           <a:p>
             <a:r>
-              <a:rPr lang="en-US" dirty="0"/>
-              <a:t>This is the core idea. A Dense(256) layer sits one step before the final softmax — 256 numbers describing what the network understood about the image before it collapses that into a class guess. After training, I 'cut' the model at that layer, building a new model whose output is those 256 features instead of the four-class prediction. I feed those features into Random Forest, Decision Tree and SVM. Layer names: CNN -&gt; dense, InceptionV3 -&gt; dense_2, Xception -&gt; dense_3, all outputting 256 features from a 128x128 input.</a:t>
+              <a:t>The core mechanism - slow right down. A network normally ends in a softmax giving four probabilities, but one layer earlier sits my Dense-256 layer, where the whole MRI is compressed into 256 numbers describing what the network understood, before collapsing into a guess. Those 256 numbers are the gold. After training normally, I cut the model there: build a new model with the same weights whose output is that dense layer instead of the softmax - a 256-number fingerprint per image. Then feed those into classical models - Random Forest, Decision Tree, SVM. Analogy: the deep network is a specialist who writes a 256-line summary; the Random Forest is a second specialist who reads only that summary and makes the call. Deep network sees; classical model decides. If asked why not softmax: classical models are robust on small data, interpretable, and give three more independent voters.</a:t>
             </a:r>
           </a:p>
         </p:txBody>
@@ -1715,8 +2075,7 @@
           <a:lstStyle/>
           <a:p>
             <a:r>
-              <a:rPr lang="en-US" dirty="0"/>
-              <a:t>Six independent opinions on every scan: three deep networks predicting directly, three classical models reading deep features. They vote — majority vote in the research notebooks. Six diverse models voting together reached 98.2% on the test set, well above any single model. The reason it works: for the ensemble to be wrong, a majority of six architecturally different models with different blind spots all have to make the same mistake on the same image — that's rare. In the live web app I upgraded this to confidence-weighted voting: summing probability vectors so a 99%-confident model counts more than a 30%-confident one, giving a real confidence percentage.</a:t>
+              <a:t>Now six independent opinions per scan: three deep networks predicting directly, three classical models reading deep features. They vote - in the notebooks a straight majority vote, and six diverse models reached 98.2%, above my best single CNN at 94. Intuition: to be wrong, a MAJORITY of six architecturally different models with different blind spots must fail the same way on the same image - rare. Then the web-app upgrade: confidence-weighted voting, summing the six probability vectors so a 99%-sure model outweighs a 30%-sure one, giving a real confidence number for the clinician.</a:t>
             </a:r>
           </a:p>
         </p:txBody>
@@ -1802,8 +2161,7 @@
           <a:lstStyle/>
           <a:p>
             <a:r>
-              <a:rPr lang="en-US" dirty="0"/>
-              <a:t>I use Grad-CAM to produce a heatmap showing which region of the MRI each model looked at. I ask: do the three models agree on where the tumour is? I measure that overlap with Intersection-over-Union, computed pairwise and averaged into one number: Ensemble Attention Agreement, EAA-IoU. High agreement means confident and consistent; low agreement is a red flag even if the class output matched — the models got there for different reasons. Below a threshold, the web app raises a clinical escalation alert. Existing explainable-ensemble papers compare a heatmap against a doctor's hand-drawn box, needing expensive annotations. My method needs no ground truth — it measures whether models agree with each other, a self-supervised uncertainty signal.</a:t>
+              <a:t>My original contribution - give it the most time. Accuracy alone isn't the goal: a model can be 98% accurate and still dangerously confident on the 2% it gets wrong. So I use Grad-CAM to see which region each of the three deep models looked at, then ask: do they agree on WHERE the tumour is? I measure overlap with Intersection-over-Union for each pair, and average the three into one Ensemble Attention Agreement score - EAA-IoU. High agreement means consistent and confident; low agreement means they're looking at different regions, a red flag even if they output the same class, so the app raises a clinical escalation alert. Why it's new: existing work compares a heatmap to a radiologist's hand-drawn box, needing annotations my dataset doesn't have. Mine measures whether the models agree with EACH OTHER - no ground truth, works on any dataset. That's the self-supervised uncertainty signal.</a:t>
             </a:r>
           </a:p>
         </p:txBody>
@@ -2489,6 +2847,85 @@
               <a:t>Student ID: E187041   |   Batch COL/LMU-T-BSC-DS/2425-FEB/3</a:t>
             </a:r>
             <a:endParaRPr lang="en-US" sz="1400" dirty="0"/>
+          </a:p>
+        </p:txBody>
+      </p:sp>
+      <p:sp>
+        <p:nvSpPr>
+          <p:cNvPr id="11" name="Rounded Rectangle 10"/>
+          <p:cNvSpPr/>
+          <p:nvPr/>
+        </p:nvSpPr>
+        <p:spPr>
+          <a:xfrm>
+            <a:off x="3529584" y="6053328"/>
+            <a:ext cx="5120640" cy="457200"/>
+          </a:xfrm>
+          <a:prstGeom prst="roundRect">
+            <a:avLst/>
+          </a:prstGeom>
+          <a:solidFill>
+            <a:srgbClr val="1FBFAE"/>
+          </a:solidFill>
+          <a:ln>
+            <a:noFill/>
+          </a:ln>
+          <a:effectLst/>
+        </p:spPr>
+        <p:style>
+          <a:lnRef idx="1">
+            <a:schemeClr val="accent1"/>
+          </a:lnRef>
+          <a:fillRef idx="3">
+            <a:schemeClr val="accent1"/>
+          </a:fillRef>
+          <a:effectRef idx="2">
+            <a:schemeClr val="accent1"/>
+          </a:effectRef>
+          <a:fontRef idx="minor">
+            <a:schemeClr val="lt1"/>
+          </a:fontRef>
+        </p:style>
+        <p:txBody>
+          <a:bodyPr rtlCol="0" anchor="ctr"/>
+          <a:lstStyle/>
+          <a:p>
+            <a:pPr algn="ctr"/>
+          </a:p>
+        </p:txBody>
+      </p:sp>
+      <p:sp>
+        <p:nvSpPr>
+          <p:cNvPr id="12" name="TextBox 11"/>
+          <p:cNvSpPr txBox="1"/>
+          <p:nvPr/>
+        </p:nvSpPr>
+        <p:spPr>
+          <a:xfrm>
+            <a:off x="3529584" y="6053328"/>
+            <a:ext cx="5120640" cy="457200"/>
+          </a:xfrm>
+          <a:prstGeom prst="rect">
+            <a:avLst/>
+          </a:prstGeom>
+          <a:noFill/>
+        </p:spPr>
+        <p:txBody>
+          <a:bodyPr wrap="square" anchor="ctr" lIns="27432" rIns="27432" tIns="27432" bIns="27432">
+            <a:spAutoFit/>
+          </a:bodyPr>
+          <a:lstStyle/>
+          <a:p>
+            <a:pPr algn="ctr"/>
+            <a:r>
+              <a:rPr sz="1150" b="1" i="0">
+                <a:solidFill>
+                  <a:srgbClr val="FFFFFF"/>
+                </a:solidFill>
+                <a:latin typeface="Calibri"/>
+              </a:rPr>
+              <a:t>PROPOSAL DEFENCE  ·  preliminary results demonstrate feasibility</a:t>
+            </a:r>
           </a:p>
         </p:txBody>
       </p:sp>
@@ -4212,6 +4649,85 @@
           </a:p>
         </p:txBody>
       </p:sp>
+      <p:sp>
+        <p:nvSpPr>
+          <p:cNvPr id="13" name="Rounded Rectangle 12"/>
+          <p:cNvSpPr/>
+          <p:nvPr/>
+        </p:nvSpPr>
+        <p:spPr>
+          <a:xfrm>
+            <a:off x="9281160" y="457200"/>
+            <a:ext cx="2148840" cy="384048"/>
+          </a:xfrm>
+          <a:prstGeom prst="roundRect">
+            <a:avLst/>
+          </a:prstGeom>
+          <a:solidFill>
+            <a:srgbClr val="1FBFAE"/>
+          </a:solidFill>
+          <a:ln>
+            <a:noFill/>
+          </a:ln>
+          <a:effectLst/>
+        </p:spPr>
+        <p:style>
+          <a:lnRef idx="1">
+            <a:schemeClr val="accent1"/>
+          </a:lnRef>
+          <a:fillRef idx="3">
+            <a:schemeClr val="accent1"/>
+          </a:fillRef>
+          <a:effectRef idx="2">
+            <a:schemeClr val="accent1"/>
+          </a:effectRef>
+          <a:fontRef idx="minor">
+            <a:schemeClr val="lt1"/>
+          </a:fontRef>
+        </p:style>
+        <p:txBody>
+          <a:bodyPr rtlCol="0" anchor="ctr"/>
+          <a:lstStyle/>
+          <a:p>
+            <a:pPr algn="ctr"/>
+          </a:p>
+        </p:txBody>
+      </p:sp>
+      <p:sp>
+        <p:nvSpPr>
+          <p:cNvPr id="14" name="TextBox 13"/>
+          <p:cNvSpPr txBox="1"/>
+          <p:nvPr/>
+        </p:nvSpPr>
+        <p:spPr>
+          <a:xfrm>
+            <a:off x="9281160" y="457200"/>
+            <a:ext cx="2148840" cy="384048"/>
+          </a:xfrm>
+          <a:prstGeom prst="rect">
+            <a:avLst/>
+          </a:prstGeom>
+          <a:noFill/>
+        </p:spPr>
+        <p:txBody>
+          <a:bodyPr wrap="square" anchor="ctr" lIns="27432" rIns="27432" tIns="27432" bIns="27432">
+            <a:spAutoFit/>
+          </a:bodyPr>
+          <a:lstStyle/>
+          <a:p>
+            <a:pPr algn="ctr"/>
+            <a:r>
+              <a:rPr sz="1100" b="1" i="0">
+                <a:solidFill>
+                  <a:srgbClr val="FFFFFF"/>
+                </a:solidFill>
+                <a:latin typeface="Calibri"/>
+              </a:rPr>
+              <a:t>PRELIMINARY</a:t>
+            </a:r>
+          </a:p>
+        </p:txBody>
+      </p:sp>
     </p:spTree>
   </p:cSld>
   <p:clrMapOvr>
@@ -9140,6 +9656,1111 @@
 </p:sld>
 </file>
 
+<file path=ppt/slides/slide19.xml><?xml version="1.0" encoding="utf-8"?>
+<p:sld xmlns:a="http://schemas.openxmlformats.org/drawingml/2006/main" xmlns:p="http://schemas.openxmlformats.org/presentationml/2006/main" xmlns:r="http://schemas.openxmlformats.org/officeDocument/2006/relationships">
+  <p:cSld>
+    <p:bg>
+      <p:bgPr>
+        <a:solidFill>
+          <a:srgbClr val="F6F9FC"/>
+        </a:solidFill>
+        <a:effectLst/>
+      </p:bgPr>
+    </p:bg>
+    <p:spTree>
+      <p:nvGrpSpPr>
+        <p:cNvPr id="1" name=""/>
+        <p:cNvGrpSpPr/>
+        <p:nvPr/>
+      </p:nvGrpSpPr>
+      <p:grpSpPr/>
+      <p:sp>
+        <p:nvSpPr>
+          <p:cNvPr id="2" name="Rectangle 1"/>
+          <p:cNvSpPr/>
+          <p:nvPr/>
+        </p:nvSpPr>
+        <p:spPr>
+          <a:xfrm>
+            <a:off x="502920" y="502920"/>
+            <a:ext cx="128016" cy="566928"/>
+          </a:xfrm>
+          <a:prstGeom prst="rect">
+            <a:avLst/>
+          </a:prstGeom>
+          <a:solidFill>
+            <a:srgbClr val="1FBFAE"/>
+          </a:solidFill>
+          <a:ln>
+            <a:noFill/>
+          </a:ln>
+          <a:effectLst/>
+        </p:spPr>
+        <p:style>
+          <a:lnRef idx="1">
+            <a:schemeClr val="accent1"/>
+          </a:lnRef>
+          <a:fillRef idx="3">
+            <a:schemeClr val="accent1"/>
+          </a:fillRef>
+          <a:effectRef idx="2">
+            <a:schemeClr val="accent1"/>
+          </a:effectRef>
+          <a:fontRef idx="minor">
+            <a:schemeClr val="lt1"/>
+          </a:fontRef>
+        </p:style>
+        <p:txBody>
+          <a:bodyPr rtlCol="0" anchor="ctr"/>
+          <a:lstStyle/>
+          <a:p>
+            <a:pPr algn="ctr"/>
+          </a:p>
+        </p:txBody>
+      </p:sp>
+      <p:sp>
+        <p:nvSpPr>
+          <p:cNvPr id="3" name="TextBox 2"/>
+          <p:cNvSpPr txBox="1"/>
+          <p:nvPr/>
+        </p:nvSpPr>
+        <p:spPr>
+          <a:xfrm>
+            <a:off x="749808" y="438912"/>
+            <a:ext cx="10881360" cy="640080"/>
+          </a:xfrm>
+          <a:prstGeom prst="rect">
+            <a:avLst/>
+          </a:prstGeom>
+          <a:noFill/>
+        </p:spPr>
+        <p:txBody>
+          <a:bodyPr wrap="square" anchor="t" lIns="27432" rIns="27432" tIns="27432" bIns="27432">
+            <a:spAutoFit/>
+          </a:bodyPr>
+          <a:lstStyle/>
+          <a:p>
+            <a:pPr algn="l"/>
+            <a:r>
+              <a:rPr sz="3000" b="1" i="0">
+                <a:solidFill>
+                  <a:srgbClr val="0A1A33"/>
+                </a:solidFill>
+                <a:latin typeface="Cambria"/>
+              </a:rPr>
+              <a:t>Where This Fits - and the Gap It Fills</a:t>
+            </a:r>
+          </a:p>
+        </p:txBody>
+      </p:sp>
+      <p:sp>
+        <p:nvSpPr>
+          <p:cNvPr id="4" name="TextBox 3"/>
+          <p:cNvSpPr txBox="1"/>
+          <p:nvPr/>
+        </p:nvSpPr>
+        <p:spPr>
+          <a:xfrm>
+            <a:off x="768096" y="1024128"/>
+            <a:ext cx="10881360" cy="365760"/>
+          </a:xfrm>
+          <a:prstGeom prst="rect">
+            <a:avLst/>
+          </a:prstGeom>
+          <a:noFill/>
+        </p:spPr>
+        <p:txBody>
+          <a:bodyPr wrap="square" anchor="t" lIns="27432" rIns="27432" tIns="27432" bIns="27432">
+            <a:spAutoFit/>
+          </a:bodyPr>
+          <a:lstStyle/>
+          <a:p>
+            <a:pPr algn="l"/>
+            <a:r>
+              <a:rPr sz="1500" b="0" i="1">
+                <a:solidFill>
+                  <a:srgbClr val="5B6B82"/>
+                </a:solidFill>
+                <a:latin typeface="Calibri"/>
+              </a:rPr>
+              <a:t>Positioning against the closest published ensemble + explainability work</a:t>
+            </a:r>
+          </a:p>
+        </p:txBody>
+      </p:sp>
+      <p:graphicFrame>
+        <p:nvGraphicFramePr>
+          <p:cNvPr id="5" name="Table 4"/>
+          <p:cNvGraphicFramePr>
+            <a:graphicFrameLocks noGrp="1"/>
+          </p:cNvGraphicFramePr>
+          <p:nvPr/>
+        </p:nvGraphicFramePr>
+        <p:xfrm>
+          <a:off x="749808" y="1627632"/>
+          <a:ext cx="10698480" cy="2697480"/>
+        </p:xfrm>
+        <a:graphic>
+          <a:graphicData uri="http://schemas.openxmlformats.org/drawingml/2006/table">
+            <a:tbl>
+              <a:tblPr>
+                <a:tableStyleId>{5C22544A-7EE6-4342-B048-85BDC9FD1C3A}</a:tableStyleId>
+              </a:tblPr>
+              <a:tblGrid>
+                <a:gridCol w="3657600"/>
+                <a:gridCol w="1965960"/>
+                <a:gridCol w="2148840"/>
+                <a:gridCol w="1554480"/>
+                <a:gridCol w="1371600"/>
+              </a:tblGrid>
+              <a:tr h="449580">
+                <a:tc>
+                  <a:txBody>
+                    <a:bodyPr wrap="square"/>
+                    <a:lstStyle/>
+                    <a:p>
+                      <a:pPr algn="l"/>
+                      <a:r>
+                        <a:rPr sz="1150" b="1" i="0">
+                          <a:solidFill>
+                            <a:srgbClr val="FFFFFF"/>
+                          </a:solidFill>
+                          <a:latin typeface="Calibri"/>
+                        </a:rPr>
+                        <a:t>Study</a:t>
+                      </a:r>
+                    </a:p>
+                  </a:txBody>
+                  <a:tcPr anchor="ctr" marL="45720" marR="45720" marT="45720" marB="45720">
+                    <a:solidFill>
+                      <a:srgbClr val="0A1A33"/>
+                    </a:solidFill>
+                  </a:tcPr>
+                </a:tc>
+                <a:tc>
+                  <a:txBody>
+                    <a:bodyPr wrap="square"/>
+                    <a:lstStyle/>
+                    <a:p>
+                      <a:pPr algn="ctr"/>
+                      <a:r>
+                        <a:rPr sz="1150" b="1" i="0">
+                          <a:solidFill>
+                            <a:srgbClr val="FFFFFF"/>
+                          </a:solidFill>
+                          <a:latin typeface="Calibri"/>
+                        </a:rPr>
+                        <a:t>Voting</a:t>
+                      </a:r>
+                    </a:p>
+                  </a:txBody>
+                  <a:tcPr anchor="ctr" marL="45720" marR="45720" marT="45720" marB="45720">
+                    <a:solidFill>
+                      <a:srgbClr val="0A1A33"/>
+                    </a:solidFill>
+                  </a:tcPr>
+                </a:tc>
+                <a:tc>
+                  <a:txBody>
+                    <a:bodyPr wrap="square"/>
+                    <a:lstStyle/>
+                    <a:p>
+                      <a:pPr algn="ctr"/>
+                      <a:r>
+                        <a:rPr sz="1150" b="1" i="0">
+                          <a:solidFill>
+                            <a:srgbClr val="FFFFFF"/>
+                          </a:solidFill>
+                          <a:latin typeface="Calibri"/>
+                        </a:rPr>
+                        <a:t>Per-model Grad-CAM</a:t>
+                      </a:r>
+                    </a:p>
+                  </a:txBody>
+                  <a:tcPr anchor="ctr" marL="45720" marR="45720" marT="45720" marB="45720">
+                    <a:solidFill>
+                      <a:srgbClr val="0A1A33"/>
+                    </a:solidFill>
+                  </a:tcPr>
+                </a:tc>
+                <a:tc>
+                  <a:txBody>
+                    <a:bodyPr wrap="square"/>
+                    <a:lstStyle/>
+                    <a:p>
+                      <a:pPr algn="ctr"/>
+                      <a:r>
+                        <a:rPr sz="1150" b="1" i="0">
+                          <a:solidFill>
+                            <a:srgbClr val="FFFFFF"/>
+                          </a:solidFill>
+                          <a:latin typeface="Calibri"/>
+                        </a:rPr>
+                        <a:t>Heatmap Fusion</a:t>
+                      </a:r>
+                    </a:p>
+                  </a:txBody>
+                  <a:tcPr anchor="ctr" marL="45720" marR="45720" marT="45720" marB="45720">
+                    <a:solidFill>
+                      <a:srgbClr val="0A1A33"/>
+                    </a:solidFill>
+                  </a:tcPr>
+                </a:tc>
+                <a:tc>
+                  <a:txBody>
+                    <a:bodyPr wrap="square"/>
+                    <a:lstStyle/>
+                    <a:p>
+                      <a:pPr algn="ctr"/>
+                      <a:r>
+                        <a:rPr sz="1150" b="1" i="0">
+                          <a:solidFill>
+                            <a:srgbClr val="FFFFFF"/>
+                          </a:solidFill>
+                          <a:latin typeface="Calibri"/>
+                        </a:rPr>
+                        <a:t>Inter-model IoU</a:t>
+                      </a:r>
+                    </a:p>
+                  </a:txBody>
+                  <a:tcPr anchor="ctr" marL="45720" marR="45720" marT="45720" marB="45720">
+                    <a:solidFill>
+                      <a:srgbClr val="0A1A33"/>
+                    </a:solidFill>
+                  </a:tcPr>
+                </a:tc>
+              </a:tr>
+              <a:tr h="449580">
+                <a:tc>
+                  <a:txBody>
+                    <a:bodyPr wrap="square"/>
+                    <a:lstStyle/>
+                    <a:p>
+                      <a:pPr algn="l"/>
+                      <a:r>
+                        <a:rPr sz="1050" b="0" i="0">
+                          <a:solidFill>
+                            <a:srgbClr val="16233B"/>
+                          </a:solidFill>
+                          <a:latin typeface="Calibri"/>
+                        </a:rPr>
+                        <a:t>Kakon et al., Cancers 2025</a:t>
+                      </a:r>
+                    </a:p>
+                  </a:txBody>
+                  <a:tcPr anchor="ctr" marL="45720" marR="45720" marT="45720" marB="45720">
+                    <a:solidFill>
+                      <a:srgbClr val="FFFFFF"/>
+                    </a:solidFill>
+                  </a:tcPr>
+                </a:tc>
+                <a:tc>
+                  <a:txBody>
+                    <a:bodyPr wrap="square"/>
+                    <a:lstStyle/>
+                    <a:p>
+                      <a:pPr algn="ctr"/>
+                      <a:r>
+                        <a:rPr sz="1050" b="0" i="0">
+                          <a:solidFill>
+                            <a:srgbClr val="16233B"/>
+                          </a:solidFill>
+                          <a:latin typeface="Calibri"/>
+                        </a:rPr>
+                        <a:t>Soft + LightGBM</a:t>
+                      </a:r>
+                    </a:p>
+                  </a:txBody>
+                  <a:tcPr anchor="ctr" marL="45720" marR="45720" marT="45720" marB="45720">
+                    <a:solidFill>
+                      <a:srgbClr val="FFFFFF"/>
+                    </a:solidFill>
+                  </a:tcPr>
+                </a:tc>
+                <a:tc>
+                  <a:txBody>
+                    <a:bodyPr wrap="square"/>
+                    <a:lstStyle/>
+                    <a:p>
+                      <a:pPr algn="ctr"/>
+                      <a:r>
+                        <a:rPr sz="1050" b="1" i="0">
+                          <a:solidFill>
+                            <a:srgbClr val="0E7C72"/>
+                          </a:solidFill>
+                          <a:latin typeface="Calibri"/>
+                        </a:rPr>
+                        <a:t>✓ </a:t>
+                      </a:r>
+                      <a:r>
+                        <a:rPr sz="1050" b="0" i="0">
+                          <a:solidFill>
+                            <a:srgbClr val="16233B"/>
+                          </a:solidFill>
+                          <a:latin typeface="Calibri"/>
+                        </a:rPr>
+                        <a:t>Grad-CAM++</a:t>
+                      </a:r>
+                    </a:p>
+                  </a:txBody>
+                  <a:tcPr anchor="ctr" marL="45720" marR="45720" marT="45720" marB="45720">
+                    <a:solidFill>
+                      <a:srgbClr val="FFFFFF"/>
+                    </a:solidFill>
+                  </a:tcPr>
+                </a:tc>
+                <a:tc>
+                  <a:txBody>
+                    <a:bodyPr wrap="square"/>
+                    <a:lstStyle/>
+                    <a:p>
+                      <a:pPr algn="ctr"/>
+                      <a:r>
+                        <a:rPr sz="1050" b="1" i="0">
+                          <a:solidFill>
+                            <a:srgbClr val="9AA7B5"/>
+                          </a:solidFill>
+                          <a:latin typeface="Calibri"/>
+                        </a:rPr>
+                        <a:t>✗</a:t>
+                      </a:r>
+                      <a:r>
+                        <a:rPr sz="1050" b="0" i="0">
+                          <a:solidFill>
+                            <a:srgbClr val="16233B"/>
+                          </a:solidFill>
+                          <a:latin typeface="Calibri"/>
+                        </a:rPr>
+                        <a:t/>
+                      </a:r>
+                    </a:p>
+                  </a:txBody>
+                  <a:tcPr anchor="ctr" marL="45720" marR="45720" marT="45720" marB="45720">
+                    <a:solidFill>
+                      <a:srgbClr val="FFFFFF"/>
+                    </a:solidFill>
+                  </a:tcPr>
+                </a:tc>
+                <a:tc>
+                  <a:txBody>
+                    <a:bodyPr wrap="square"/>
+                    <a:lstStyle/>
+                    <a:p>
+                      <a:pPr algn="ctr"/>
+                      <a:r>
+                        <a:rPr sz="1050" b="1" i="0">
+                          <a:solidFill>
+                            <a:srgbClr val="9AA7B5"/>
+                          </a:solidFill>
+                          <a:latin typeface="Calibri"/>
+                        </a:rPr>
+                        <a:t>✗</a:t>
+                      </a:r>
+                      <a:r>
+                        <a:rPr sz="1050" b="0" i="0">
+                          <a:solidFill>
+                            <a:srgbClr val="16233B"/>
+                          </a:solidFill>
+                          <a:latin typeface="Calibri"/>
+                        </a:rPr>
+                        <a:t/>
+                      </a:r>
+                    </a:p>
+                  </a:txBody>
+                  <a:tcPr anchor="ctr" marL="45720" marR="45720" marT="45720" marB="45720">
+                    <a:solidFill>
+                      <a:srgbClr val="FFFFFF"/>
+                    </a:solidFill>
+                  </a:tcPr>
+                </a:tc>
+              </a:tr>
+              <a:tr h="449580">
+                <a:tc>
+                  <a:txBody>
+                    <a:bodyPr wrap="square"/>
+                    <a:lstStyle/>
+                    <a:p>
+                      <a:pPr algn="l"/>
+                      <a:r>
+                        <a:rPr sz="1050" b="0" i="0">
+                          <a:solidFill>
+                            <a:srgbClr val="16233B"/>
+                          </a:solidFill>
+                          <a:latin typeface="Calibri"/>
+                        </a:rPr>
+                        <a:t>Comput. Biol. Med. 2025</a:t>
+                      </a:r>
+                    </a:p>
+                  </a:txBody>
+                  <a:tcPr anchor="ctr" marL="45720" marR="45720" marT="45720" marB="45720">
+                    <a:solidFill>
+                      <a:srgbClr val="FFFFFF"/>
+                    </a:solidFill>
+                  </a:tcPr>
+                </a:tc>
+                <a:tc>
+                  <a:txBody>
+                    <a:bodyPr wrap="square"/>
+                    <a:lstStyle/>
+                    <a:p>
+                      <a:pPr algn="ctr"/>
+                      <a:r>
+                        <a:rPr sz="1050" b="0" i="0">
+                          <a:solidFill>
+                            <a:srgbClr val="16233B"/>
+                          </a:solidFill>
+                          <a:latin typeface="Calibri"/>
+                        </a:rPr>
+                        <a:t>Soft vote</a:t>
+                      </a:r>
+                    </a:p>
+                  </a:txBody>
+                  <a:tcPr anchor="ctr" marL="45720" marR="45720" marT="45720" marB="45720">
+                    <a:solidFill>
+                      <a:srgbClr val="FFFFFF"/>
+                    </a:solidFill>
+                  </a:tcPr>
+                </a:tc>
+                <a:tc>
+                  <a:txBody>
+                    <a:bodyPr wrap="square"/>
+                    <a:lstStyle/>
+                    <a:p>
+                      <a:pPr algn="ctr"/>
+                      <a:r>
+                        <a:rPr sz="1050" b="1" i="0">
+                          <a:solidFill>
+                            <a:srgbClr val="0E7C72"/>
+                          </a:solidFill>
+                          <a:latin typeface="Calibri"/>
+                        </a:rPr>
+                        <a:t>✓ </a:t>
+                      </a:r>
+                      <a:r>
+                        <a:rPr sz="1050" b="0" i="0">
+                          <a:solidFill>
+                            <a:srgbClr val="16233B"/>
+                          </a:solidFill>
+                          <a:latin typeface="Calibri"/>
+                        </a:rPr>
+                        <a:t/>
+                      </a:r>
+                    </a:p>
+                  </a:txBody>
+                  <a:tcPr anchor="ctr" marL="45720" marR="45720" marT="45720" marB="45720">
+                    <a:solidFill>
+                      <a:srgbClr val="FFFFFF"/>
+                    </a:solidFill>
+                  </a:tcPr>
+                </a:tc>
+                <a:tc>
+                  <a:txBody>
+                    <a:bodyPr wrap="square"/>
+                    <a:lstStyle/>
+                    <a:p>
+                      <a:pPr algn="ctr"/>
+                      <a:r>
+                        <a:rPr sz="1050" b="1" i="0">
+                          <a:solidFill>
+                            <a:srgbClr val="9AA7B5"/>
+                          </a:solidFill>
+                          <a:latin typeface="Calibri"/>
+                        </a:rPr>
+                        <a:t>✗</a:t>
+                      </a:r>
+                      <a:r>
+                        <a:rPr sz="1050" b="0" i="0">
+                          <a:solidFill>
+                            <a:srgbClr val="16233B"/>
+                          </a:solidFill>
+                          <a:latin typeface="Calibri"/>
+                        </a:rPr>
+                        <a:t/>
+                      </a:r>
+                    </a:p>
+                  </a:txBody>
+                  <a:tcPr anchor="ctr" marL="45720" marR="45720" marT="45720" marB="45720">
+                    <a:solidFill>
+                      <a:srgbClr val="FFFFFF"/>
+                    </a:solidFill>
+                  </a:tcPr>
+                </a:tc>
+                <a:tc>
+                  <a:txBody>
+                    <a:bodyPr wrap="square"/>
+                    <a:lstStyle/>
+                    <a:p>
+                      <a:pPr algn="ctr"/>
+                      <a:r>
+                        <a:rPr sz="1050" b="0" i="0">
+                          <a:solidFill>
+                            <a:srgbClr val="16233B"/>
+                          </a:solidFill>
+                          <a:latin typeface="Calibri"/>
+                        </a:rPr>
+                        <a:t>vs annotation only</a:t>
+                      </a:r>
+                    </a:p>
+                  </a:txBody>
+                  <a:tcPr anchor="ctr" marL="45720" marR="45720" marT="45720" marB="45720">
+                    <a:solidFill>
+                      <a:srgbClr val="FFFFFF"/>
+                    </a:solidFill>
+                  </a:tcPr>
+                </a:tc>
+              </a:tr>
+              <a:tr h="449580">
+                <a:tc>
+                  <a:txBody>
+                    <a:bodyPr wrap="square"/>
+                    <a:lstStyle/>
+                    <a:p>
+                      <a:pPr algn="l"/>
+                      <a:r>
+                        <a:rPr sz="1050" b="0" i="0">
+                          <a:solidFill>
+                            <a:srgbClr val="16233B"/>
+                          </a:solidFill>
+                          <a:latin typeface="Calibri"/>
+                        </a:rPr>
+                        <a:t>Adaptive Ensemble, Sci. Rep. 2025</a:t>
+                      </a:r>
+                    </a:p>
+                  </a:txBody>
+                  <a:tcPr anchor="ctr" marL="45720" marR="45720" marT="45720" marB="45720">
+                    <a:solidFill>
+                      <a:srgbClr val="FFFFFF"/>
+                    </a:solidFill>
+                  </a:tcPr>
+                </a:tc>
+                <a:tc>
+                  <a:txBody>
+                    <a:bodyPr wrap="square"/>
+                    <a:lstStyle/>
+                    <a:p>
+                      <a:pPr algn="ctr"/>
+                      <a:r>
+                        <a:rPr sz="1050" b="0" i="0">
+                          <a:solidFill>
+                            <a:srgbClr val="16233B"/>
+                          </a:solidFill>
+                          <a:latin typeface="Calibri"/>
+                        </a:rPr>
+                        <a:t>Adaptive weights</a:t>
+                      </a:r>
+                    </a:p>
+                  </a:txBody>
+                  <a:tcPr anchor="ctr" marL="45720" marR="45720" marT="45720" marB="45720">
+                    <a:solidFill>
+                      <a:srgbClr val="FFFFFF"/>
+                    </a:solidFill>
+                  </a:tcPr>
+                </a:tc>
+                <a:tc>
+                  <a:txBody>
+                    <a:bodyPr wrap="square"/>
+                    <a:lstStyle/>
+                    <a:p>
+                      <a:pPr algn="ctr"/>
+                      <a:r>
+                        <a:rPr sz="1050" b="1" i="0">
+                          <a:solidFill>
+                            <a:srgbClr val="0E7C72"/>
+                          </a:solidFill>
+                          <a:latin typeface="Calibri"/>
+                        </a:rPr>
+                        <a:t>✓ </a:t>
+                      </a:r>
+                      <a:r>
+                        <a:rPr sz="1050" b="0" i="0">
+                          <a:solidFill>
+                            <a:srgbClr val="16233B"/>
+                          </a:solidFill>
+                          <a:latin typeface="Calibri"/>
+                        </a:rPr>
+                        <a:t> +SHAP/LIME</a:t>
+                      </a:r>
+                    </a:p>
+                  </a:txBody>
+                  <a:tcPr anchor="ctr" marL="45720" marR="45720" marT="45720" marB="45720">
+                    <a:solidFill>
+                      <a:srgbClr val="FFFFFF"/>
+                    </a:solidFill>
+                  </a:tcPr>
+                </a:tc>
+                <a:tc>
+                  <a:txBody>
+                    <a:bodyPr wrap="square"/>
+                    <a:lstStyle/>
+                    <a:p>
+                      <a:pPr algn="ctr"/>
+                      <a:r>
+                        <a:rPr sz="1050" b="1" i="0">
+                          <a:solidFill>
+                            <a:srgbClr val="9AA7B5"/>
+                          </a:solidFill>
+                          <a:latin typeface="Calibri"/>
+                        </a:rPr>
+                        <a:t>✗</a:t>
+                      </a:r>
+                      <a:r>
+                        <a:rPr sz="1050" b="0" i="0">
+                          <a:solidFill>
+                            <a:srgbClr val="16233B"/>
+                          </a:solidFill>
+                          <a:latin typeface="Calibri"/>
+                        </a:rPr>
+                        <a:t/>
+                      </a:r>
+                    </a:p>
+                  </a:txBody>
+                  <a:tcPr anchor="ctr" marL="45720" marR="45720" marT="45720" marB="45720">
+                    <a:solidFill>
+                      <a:srgbClr val="FFFFFF"/>
+                    </a:solidFill>
+                  </a:tcPr>
+                </a:tc>
+                <a:tc>
+                  <a:txBody>
+                    <a:bodyPr wrap="square"/>
+                    <a:lstStyle/>
+                    <a:p>
+                      <a:pPr algn="ctr"/>
+                      <a:r>
+                        <a:rPr sz="1050" b="1" i="0">
+                          <a:solidFill>
+                            <a:srgbClr val="9AA7B5"/>
+                          </a:solidFill>
+                          <a:latin typeface="Calibri"/>
+                        </a:rPr>
+                        <a:t>✗</a:t>
+                      </a:r>
+                      <a:r>
+                        <a:rPr sz="1050" b="0" i="0">
+                          <a:solidFill>
+                            <a:srgbClr val="16233B"/>
+                          </a:solidFill>
+                          <a:latin typeface="Calibri"/>
+                        </a:rPr>
+                        <a:t/>
+                      </a:r>
+                    </a:p>
+                  </a:txBody>
+                  <a:tcPr anchor="ctr" marL="45720" marR="45720" marT="45720" marB="45720">
+                    <a:solidFill>
+                      <a:srgbClr val="FFFFFF"/>
+                    </a:solidFill>
+                  </a:tcPr>
+                </a:tc>
+              </a:tr>
+              <a:tr h="449580">
+                <a:tc>
+                  <a:txBody>
+                    <a:bodyPr wrap="square"/>
+                    <a:lstStyle/>
+                    <a:p>
+                      <a:pPr algn="l"/>
+                      <a:r>
+                        <a:rPr sz="1050" b="0" i="0">
+                          <a:solidFill>
+                            <a:srgbClr val="16233B"/>
+                          </a:solidFill>
+                          <a:latin typeface="Calibri"/>
+                        </a:rPr>
+                        <a:t>Two-step Majority Vote, 2025</a:t>
+                      </a:r>
+                    </a:p>
+                  </a:txBody>
+                  <a:tcPr anchor="ctr" marL="45720" marR="45720" marT="45720" marB="45720">
+                    <a:solidFill>
+                      <a:srgbClr val="FFFFFF"/>
+                    </a:solidFill>
+                  </a:tcPr>
+                </a:tc>
+                <a:tc>
+                  <a:txBody>
+                    <a:bodyPr wrap="square"/>
+                    <a:lstStyle/>
+                    <a:p>
+                      <a:pPr algn="ctr"/>
+                      <a:r>
+                        <a:rPr sz="1050" b="0" i="0">
+                          <a:solidFill>
+                            <a:srgbClr val="16233B"/>
+                          </a:solidFill>
+                          <a:latin typeface="Calibri"/>
+                        </a:rPr>
+                        <a:t>Majority vote</a:t>
+                      </a:r>
+                    </a:p>
+                  </a:txBody>
+                  <a:tcPr anchor="ctr" marL="45720" marR="45720" marT="45720" marB="45720">
+                    <a:solidFill>
+                      <a:srgbClr val="FFFFFF"/>
+                    </a:solidFill>
+                  </a:tcPr>
+                </a:tc>
+                <a:tc>
+                  <a:txBody>
+                    <a:bodyPr wrap="square"/>
+                    <a:lstStyle/>
+                    <a:p>
+                      <a:pPr algn="ctr"/>
+                      <a:r>
+                        <a:rPr sz="1050" b="1" i="0">
+                          <a:solidFill>
+                            <a:srgbClr val="0E7C72"/>
+                          </a:solidFill>
+                          <a:latin typeface="Calibri"/>
+                        </a:rPr>
+                        <a:t>✓ </a:t>
+                      </a:r>
+                      <a:r>
+                        <a:rPr sz="1050" b="0" i="0">
+                          <a:solidFill>
+                            <a:srgbClr val="16233B"/>
+                          </a:solidFill>
+                          <a:latin typeface="Calibri"/>
+                        </a:rPr>
+                        <a:t> +LIME</a:t>
+                      </a:r>
+                    </a:p>
+                  </a:txBody>
+                  <a:tcPr anchor="ctr" marL="45720" marR="45720" marT="45720" marB="45720">
+                    <a:solidFill>
+                      <a:srgbClr val="FFFFFF"/>
+                    </a:solidFill>
+                  </a:tcPr>
+                </a:tc>
+                <a:tc>
+                  <a:txBody>
+                    <a:bodyPr wrap="square"/>
+                    <a:lstStyle/>
+                    <a:p>
+                      <a:pPr algn="ctr"/>
+                      <a:r>
+                        <a:rPr sz="1050" b="1" i="0">
+                          <a:solidFill>
+                            <a:srgbClr val="9AA7B5"/>
+                          </a:solidFill>
+                          <a:latin typeface="Calibri"/>
+                        </a:rPr>
+                        <a:t>✗</a:t>
+                      </a:r>
+                      <a:r>
+                        <a:rPr sz="1050" b="0" i="0">
+                          <a:solidFill>
+                            <a:srgbClr val="16233B"/>
+                          </a:solidFill>
+                          <a:latin typeface="Calibri"/>
+                        </a:rPr>
+                        <a:t/>
+                      </a:r>
+                    </a:p>
+                  </a:txBody>
+                  <a:tcPr anchor="ctr" marL="45720" marR="45720" marT="45720" marB="45720">
+                    <a:solidFill>
+                      <a:srgbClr val="FFFFFF"/>
+                    </a:solidFill>
+                  </a:tcPr>
+                </a:tc>
+                <a:tc>
+                  <a:txBody>
+                    <a:bodyPr wrap="square"/>
+                    <a:lstStyle/>
+                    <a:p>
+                      <a:pPr algn="ctr"/>
+                      <a:r>
+                        <a:rPr sz="1050" b="1" i="0">
+                          <a:solidFill>
+                            <a:srgbClr val="9AA7B5"/>
+                          </a:solidFill>
+                          <a:latin typeface="Calibri"/>
+                        </a:rPr>
+                        <a:t>✗</a:t>
+                      </a:r>
+                      <a:r>
+                        <a:rPr sz="1050" b="0" i="0">
+                          <a:solidFill>
+                            <a:srgbClr val="16233B"/>
+                          </a:solidFill>
+                          <a:latin typeface="Calibri"/>
+                        </a:rPr>
+                        <a:t/>
+                      </a:r>
+                    </a:p>
+                  </a:txBody>
+                  <a:tcPr anchor="ctr" marL="45720" marR="45720" marT="45720" marB="45720">
+                    <a:solidFill>
+                      <a:srgbClr val="FFFFFF"/>
+                    </a:solidFill>
+                  </a:tcPr>
+                </a:tc>
+              </a:tr>
+              <a:tr h="449580">
+                <a:tc>
+                  <a:txBody>
+                    <a:bodyPr wrap="square"/>
+                    <a:lstStyle/>
+                    <a:p>
+                      <a:pPr algn="l"/>
+                      <a:r>
+                        <a:rPr sz="1050" b="1" i="0">
+                          <a:solidFill>
+                            <a:srgbClr val="0A1A33"/>
+                          </a:solidFill>
+                          <a:latin typeface="Calibri"/>
+                        </a:rPr>
+                        <a:t>THIS WORK</a:t>
+                      </a:r>
+                    </a:p>
+                  </a:txBody>
+                  <a:tcPr anchor="ctr" marL="45720" marR="45720" marT="45720" marB="45720">
+                    <a:solidFill>
+                      <a:srgbClr val="F0FBFA"/>
+                    </a:solidFill>
+                  </a:tcPr>
+                </a:tc>
+                <a:tc>
+                  <a:txBody>
+                    <a:bodyPr wrap="square"/>
+                    <a:lstStyle/>
+                    <a:p>
+                      <a:pPr algn="ctr"/>
+                      <a:r>
+                        <a:rPr sz="1050" b="1" i="0">
+                          <a:solidFill>
+                            <a:srgbClr val="0A1A33"/>
+                          </a:solidFill>
+                          <a:latin typeface="Calibri"/>
+                        </a:rPr>
+                        <a:t>Confidence-weighted</a:t>
+                      </a:r>
+                    </a:p>
+                  </a:txBody>
+                  <a:tcPr anchor="ctr" marL="45720" marR="45720" marT="45720" marB="45720">
+                    <a:solidFill>
+                      <a:srgbClr val="F0FBFA"/>
+                    </a:solidFill>
+                  </a:tcPr>
+                </a:tc>
+                <a:tc>
+                  <a:txBody>
+                    <a:bodyPr wrap="square"/>
+                    <a:lstStyle/>
+                    <a:p>
+                      <a:pPr algn="ctr"/>
+                      <a:r>
+                        <a:rPr sz="1050" b="1" i="0">
+                          <a:solidFill>
+                            <a:srgbClr val="0E7C72"/>
+                          </a:solidFill>
+                          <a:latin typeface="Calibri"/>
+                        </a:rPr>
+                        <a:t>✓ </a:t>
+                      </a:r>
+                      <a:r>
+                        <a:rPr sz="1050" b="1" i="0">
+                          <a:solidFill>
+                            <a:srgbClr val="0A1A33"/>
+                          </a:solidFill>
+                          <a:latin typeface="Calibri"/>
+                        </a:rPr>
+                        <a:t/>
+                      </a:r>
+                    </a:p>
+                  </a:txBody>
+                  <a:tcPr anchor="ctr" marL="45720" marR="45720" marT="45720" marB="45720">
+                    <a:solidFill>
+                      <a:srgbClr val="F0FBFA"/>
+                    </a:solidFill>
+                  </a:tcPr>
+                </a:tc>
+                <a:tc>
+                  <a:txBody>
+                    <a:bodyPr wrap="square"/>
+                    <a:lstStyle/>
+                    <a:p>
+                      <a:pPr algn="ctr"/>
+                      <a:r>
+                        <a:rPr sz="1050" b="1" i="0">
+                          <a:solidFill>
+                            <a:srgbClr val="0E7C72"/>
+                          </a:solidFill>
+                          <a:latin typeface="Calibri"/>
+                        </a:rPr>
+                        <a:t>✓ </a:t>
+                      </a:r>
+                      <a:r>
+                        <a:rPr sz="1050" b="1" i="0">
+                          <a:solidFill>
+                            <a:srgbClr val="0A1A33"/>
+                          </a:solidFill>
+                          <a:latin typeface="Calibri"/>
+                        </a:rPr>
+                        <a:t> weighted avg</a:t>
+                      </a:r>
+                    </a:p>
+                  </a:txBody>
+                  <a:tcPr anchor="ctr" marL="45720" marR="45720" marT="45720" marB="45720">
+                    <a:solidFill>
+                      <a:srgbClr val="F0FBFA"/>
+                    </a:solidFill>
+                  </a:tcPr>
+                </a:tc>
+                <a:tc>
+                  <a:txBody>
+                    <a:bodyPr wrap="square"/>
+                    <a:lstStyle/>
+                    <a:p>
+                      <a:pPr algn="ctr"/>
+                      <a:r>
+                        <a:rPr sz="1050" b="1" i="0">
+                          <a:solidFill>
+                            <a:srgbClr val="0E7C72"/>
+                          </a:solidFill>
+                          <a:latin typeface="Calibri"/>
+                        </a:rPr>
+                        <a:t>✓ </a:t>
+                      </a:r>
+                      <a:r>
+                        <a:rPr sz="1050" b="1" i="0">
+                          <a:solidFill>
+                            <a:srgbClr val="0A1A33"/>
+                          </a:solidFill>
+                          <a:latin typeface="Calibri"/>
+                        </a:rPr>
+                        <a:t> EAA-IoU</a:t>
+                      </a:r>
+                    </a:p>
+                  </a:txBody>
+                  <a:tcPr anchor="ctr" marL="45720" marR="45720" marT="45720" marB="45720">
+                    <a:solidFill>
+                      <a:srgbClr val="F0FBFA"/>
+                    </a:solidFill>
+                  </a:tcPr>
+                </a:tc>
+              </a:tr>
+            </a:tbl>
+          </a:graphicData>
+        </a:graphic>
+      </p:graphicFrame>
+      <p:sp>
+        <p:nvSpPr>
+          <p:cNvPr id="6" name="Rounded Rectangle 5"/>
+          <p:cNvSpPr/>
+          <p:nvPr/>
+        </p:nvSpPr>
+        <p:spPr>
+          <a:xfrm>
+            <a:off x="749808" y="4572000"/>
+            <a:ext cx="10698480" cy="960120"/>
+          </a:xfrm>
+          <a:prstGeom prst="roundRect">
+            <a:avLst/>
+          </a:prstGeom>
+          <a:solidFill>
+            <a:srgbClr val="F0FBFA"/>
+          </a:solidFill>
+          <a:ln w="12700">
+            <a:solidFill>
+              <a:srgbClr val="E2E8F0"/>
+            </a:solidFill>
+          </a:ln>
+          <a:effectLst/>
+        </p:spPr>
+        <p:style>
+          <a:lnRef idx="1">
+            <a:schemeClr val="accent1"/>
+          </a:lnRef>
+          <a:fillRef idx="3">
+            <a:schemeClr val="accent1"/>
+          </a:fillRef>
+          <a:effectRef idx="2">
+            <a:schemeClr val="accent1"/>
+          </a:effectRef>
+          <a:fontRef idx="minor">
+            <a:schemeClr val="lt1"/>
+          </a:fontRef>
+        </p:style>
+        <p:txBody>
+          <a:bodyPr rtlCol="0" anchor="ctr"/>
+          <a:lstStyle/>
+          <a:p>
+            <a:pPr algn="ctr"/>
+          </a:p>
+        </p:txBody>
+      </p:sp>
+      <p:sp>
+        <p:nvSpPr>
+          <p:cNvPr id="7" name="TextBox 6"/>
+          <p:cNvSpPr txBox="1"/>
+          <p:nvPr/>
+        </p:nvSpPr>
+        <p:spPr>
+          <a:xfrm>
+            <a:off x="960120" y="4681728"/>
+            <a:ext cx="10332720" cy="777240"/>
+          </a:xfrm>
+          <a:prstGeom prst="rect">
+            <a:avLst/>
+          </a:prstGeom>
+          <a:noFill/>
+        </p:spPr>
+        <p:txBody>
+          <a:bodyPr wrap="square" anchor="ctr" lIns="27432" rIns="27432" tIns="27432" bIns="27432">
+            <a:spAutoFit/>
+          </a:bodyPr>
+          <a:lstStyle/>
+          <a:p>
+            <a:pPr algn="l"/>
+            <a:r>
+              <a:rPr sz="1300" b="1" i="0">
+                <a:solidFill>
+                  <a:srgbClr val="0E7C72"/>
+                </a:solidFill>
+                <a:latin typeface="Calibri"/>
+              </a:rPr>
+              <a:t>The gap:  </a:t>
+            </a:r>
+            <a:r>
+              <a:rPr sz="1250" b="0" i="0">
+                <a:solidFill>
+                  <a:srgbClr val="16233B"/>
+                </a:solidFill>
+                <a:latin typeface="Calibri"/>
+              </a:rPr>
+              <a:t>voting and per-model Grad-CAM are well covered. But no published brain-tumour paper occupies the last two columns together - fusing heatmaps into a consensus map, and measuring </a:t>
+            </a:r>
+            <a:r>
+              <a:rPr sz="1250" b="1" i="0">
+                <a:solidFill>
+                  <a:srgbClr val="16233B"/>
+                </a:solidFill>
+                <a:latin typeface="Calibri"/>
+              </a:rPr>
+              <a:t>inter-model IoU as an agreement signal</a:t>
+            </a:r>
+            <a:r>
+              <a:rPr sz="1250" b="0" i="0">
+                <a:solidFill>
+                  <a:srgbClr val="16233B"/>
+                </a:solidFill>
+                <a:latin typeface="Calibri"/>
+              </a:rPr>
+              <a:t>. Prior IoU work compares against radiologist annotations, not the models themselves. That precise, unoccupied gap is my contribution.</a:t>
+            </a:r>
+          </a:p>
+        </p:txBody>
+      </p:sp>
+    </p:spTree>
+  </p:cSld>
+  <p:clrMapOvr>
+    <a:masterClrMapping/>
+  </p:clrMapOvr>
+</p:sld>
+</file>
+
 <file path=ppt/slides/slide2.xml><?xml version="1.0" encoding="utf-8"?>
 <p:sld xmlns:a="http://schemas.openxmlformats.org/drawingml/2006/main" xmlns:r="http://schemas.openxmlformats.org/officeDocument/2006/relationships" xmlns:p="http://schemas.openxmlformats.org/presentationml/2006/main">
   <p:cSld name="Slide 2">
@@ -9792,6 +11413,1760 @@
               <a:t>Aim: build an AI system that is not just accurate, but honest about when it isn't sure.</a:t>
             </a:r>
             <a:endParaRPr lang="en-US" sz="1500" dirty="0"/>
+          </a:p>
+        </p:txBody>
+      </p:sp>
+    </p:spTree>
+  </p:cSld>
+  <p:clrMapOvr>
+    <a:masterClrMapping/>
+  </p:clrMapOvr>
+</p:sld>
+</file>
+
+<file path=ppt/slides/slide20.xml><?xml version="1.0" encoding="utf-8"?>
+<p:sld xmlns:a="http://schemas.openxmlformats.org/drawingml/2006/main" xmlns:p="http://schemas.openxmlformats.org/presentationml/2006/main" xmlns:r="http://schemas.openxmlformats.org/officeDocument/2006/relationships">
+  <p:cSld>
+    <p:bg>
+      <p:bgPr>
+        <a:solidFill>
+          <a:srgbClr val="F6F9FC"/>
+        </a:solidFill>
+        <a:effectLst/>
+      </p:bgPr>
+    </p:bg>
+    <p:spTree>
+      <p:nvGrpSpPr>
+        <p:cNvPr id="1" name=""/>
+        <p:cNvGrpSpPr/>
+        <p:nvPr/>
+      </p:nvGrpSpPr>
+      <p:grpSpPr/>
+      <p:sp>
+        <p:nvSpPr>
+          <p:cNvPr id="2" name="Rectangle 1"/>
+          <p:cNvSpPr/>
+          <p:nvPr/>
+        </p:nvSpPr>
+        <p:spPr>
+          <a:xfrm>
+            <a:off x="502920" y="502920"/>
+            <a:ext cx="128016" cy="566928"/>
+          </a:xfrm>
+          <a:prstGeom prst="rect">
+            <a:avLst/>
+          </a:prstGeom>
+          <a:solidFill>
+            <a:srgbClr val="1FBFAE"/>
+          </a:solidFill>
+          <a:ln>
+            <a:noFill/>
+          </a:ln>
+          <a:effectLst/>
+        </p:spPr>
+        <p:style>
+          <a:lnRef idx="1">
+            <a:schemeClr val="accent1"/>
+          </a:lnRef>
+          <a:fillRef idx="3">
+            <a:schemeClr val="accent1"/>
+          </a:fillRef>
+          <a:effectRef idx="2">
+            <a:schemeClr val="accent1"/>
+          </a:effectRef>
+          <a:fontRef idx="minor">
+            <a:schemeClr val="lt1"/>
+          </a:fontRef>
+        </p:style>
+        <p:txBody>
+          <a:bodyPr rtlCol="0" anchor="ctr"/>
+          <a:lstStyle/>
+          <a:p>
+            <a:pPr algn="ctr"/>
+          </a:p>
+        </p:txBody>
+      </p:sp>
+      <p:sp>
+        <p:nvSpPr>
+          <p:cNvPr id="3" name="TextBox 2"/>
+          <p:cNvSpPr txBox="1"/>
+          <p:nvPr/>
+        </p:nvSpPr>
+        <p:spPr>
+          <a:xfrm>
+            <a:off x="749808" y="438912"/>
+            <a:ext cx="10881360" cy="640080"/>
+          </a:xfrm>
+          <a:prstGeom prst="rect">
+            <a:avLst/>
+          </a:prstGeom>
+          <a:noFill/>
+        </p:spPr>
+        <p:txBody>
+          <a:bodyPr wrap="square" anchor="t" lIns="27432" rIns="27432" tIns="27432" bIns="27432">
+            <a:spAutoFit/>
+          </a:bodyPr>
+          <a:lstStyle/>
+          <a:p>
+            <a:pPr algn="l"/>
+            <a:r>
+              <a:rPr sz="3000" b="1" i="0">
+                <a:solidFill>
+                  <a:srgbClr val="0A1A33"/>
+                </a:solidFill>
+                <a:latin typeface="Cambria"/>
+              </a:rPr>
+              <a:t>Project Plan - 16 Weeks</a:t>
+            </a:r>
+          </a:p>
+        </p:txBody>
+      </p:sp>
+      <p:sp>
+        <p:nvSpPr>
+          <p:cNvPr id="4" name="TextBox 3"/>
+          <p:cNvSpPr txBox="1"/>
+          <p:nvPr/>
+        </p:nvSpPr>
+        <p:spPr>
+          <a:xfrm>
+            <a:off x="768096" y="1024128"/>
+            <a:ext cx="10881360" cy="365760"/>
+          </a:xfrm>
+          <a:prstGeom prst="rect">
+            <a:avLst/>
+          </a:prstGeom>
+          <a:noFill/>
+        </p:spPr>
+        <p:txBody>
+          <a:bodyPr wrap="square" anchor="t" lIns="27432" rIns="27432" tIns="27432" bIns="27432">
+            <a:spAutoFit/>
+          </a:bodyPr>
+          <a:lstStyle/>
+          <a:p>
+            <a:pPr algn="l"/>
+            <a:r>
+              <a:rPr sz="1500" b="0" i="1">
+                <a:solidFill>
+                  <a:srgbClr val="5B6B82"/>
+                </a:solidFill>
+                <a:latin typeface="Calibri"/>
+              </a:rPr>
+              <a:t>Six phases from literature review to final documentation</a:t>
+            </a:r>
+          </a:p>
+        </p:txBody>
+      </p:sp>
+      <p:sp>
+        <p:nvSpPr>
+          <p:cNvPr id="5" name="Rectangle 4"/>
+          <p:cNvSpPr/>
+          <p:nvPr/>
+        </p:nvSpPr>
+        <p:spPr>
+          <a:xfrm>
+            <a:off x="3977639" y="1618487"/>
+            <a:ext cx="10972" cy="3657600"/>
+          </a:xfrm>
+          <a:prstGeom prst="rect">
+            <a:avLst/>
+          </a:prstGeom>
+          <a:solidFill>
+            <a:srgbClr val="E6ECF3"/>
+          </a:solidFill>
+          <a:ln>
+            <a:noFill/>
+          </a:ln>
+          <a:effectLst/>
+        </p:spPr>
+        <p:style>
+          <a:lnRef idx="1">
+            <a:schemeClr val="accent1"/>
+          </a:lnRef>
+          <a:fillRef idx="3">
+            <a:schemeClr val="accent1"/>
+          </a:fillRef>
+          <a:effectRef idx="2">
+            <a:schemeClr val="accent1"/>
+          </a:effectRef>
+          <a:fontRef idx="minor">
+            <a:schemeClr val="lt1"/>
+          </a:fontRef>
+        </p:style>
+        <p:txBody>
+          <a:bodyPr rtlCol="0" anchor="ctr"/>
+          <a:lstStyle/>
+          <a:p>
+            <a:pPr algn="ctr"/>
+          </a:p>
+        </p:txBody>
+      </p:sp>
+      <p:sp>
+        <p:nvSpPr>
+          <p:cNvPr id="6" name="TextBox 5"/>
+          <p:cNvSpPr txBox="1"/>
+          <p:nvPr/>
+        </p:nvSpPr>
+        <p:spPr>
+          <a:xfrm>
+            <a:off x="3794759" y="1581911"/>
+            <a:ext cx="365760" cy="228600"/>
+          </a:xfrm>
+          <a:prstGeom prst="rect">
+            <a:avLst/>
+          </a:prstGeom>
+          <a:noFill/>
+        </p:spPr>
+        <p:txBody>
+          <a:bodyPr wrap="square" anchor="t" lIns="27432" rIns="27432" tIns="27432" bIns="27432">
+            <a:spAutoFit/>
+          </a:bodyPr>
+          <a:lstStyle/>
+          <a:p>
+            <a:pPr algn="ctr"/>
+            <a:r>
+              <a:rPr sz="900" b="0" i="0">
+                <a:solidFill>
+                  <a:srgbClr val="9AA7B5"/>
+                </a:solidFill>
+                <a:latin typeface="Calibri"/>
+              </a:rPr>
+              <a:t>W1</a:t>
+            </a:r>
+          </a:p>
+        </p:txBody>
+      </p:sp>
+      <p:sp>
+        <p:nvSpPr>
+          <p:cNvPr id="7" name="Rectangle 6"/>
+          <p:cNvSpPr/>
+          <p:nvPr/>
+        </p:nvSpPr>
+        <p:spPr>
+          <a:xfrm>
+            <a:off x="4903470" y="1618487"/>
+            <a:ext cx="10972" cy="3657600"/>
+          </a:xfrm>
+          <a:prstGeom prst="rect">
+            <a:avLst/>
+          </a:prstGeom>
+          <a:solidFill>
+            <a:srgbClr val="E6ECF3"/>
+          </a:solidFill>
+          <a:ln>
+            <a:noFill/>
+          </a:ln>
+          <a:effectLst/>
+        </p:spPr>
+        <p:style>
+          <a:lnRef idx="1">
+            <a:schemeClr val="accent1"/>
+          </a:lnRef>
+          <a:fillRef idx="3">
+            <a:schemeClr val="accent1"/>
+          </a:fillRef>
+          <a:effectRef idx="2">
+            <a:schemeClr val="accent1"/>
+          </a:effectRef>
+          <a:fontRef idx="minor">
+            <a:schemeClr val="lt1"/>
+          </a:fontRef>
+        </p:style>
+        <p:txBody>
+          <a:bodyPr rtlCol="0" anchor="ctr"/>
+          <a:lstStyle/>
+          <a:p>
+            <a:pPr algn="ctr"/>
+          </a:p>
+        </p:txBody>
+      </p:sp>
+      <p:sp>
+        <p:nvSpPr>
+          <p:cNvPr id="8" name="TextBox 7"/>
+          <p:cNvSpPr txBox="1"/>
+          <p:nvPr/>
+        </p:nvSpPr>
+        <p:spPr>
+          <a:xfrm>
+            <a:off x="4720590" y="1581911"/>
+            <a:ext cx="365760" cy="228600"/>
+          </a:xfrm>
+          <a:prstGeom prst="rect">
+            <a:avLst/>
+          </a:prstGeom>
+          <a:noFill/>
+        </p:spPr>
+        <p:txBody>
+          <a:bodyPr wrap="square" anchor="t" lIns="27432" rIns="27432" tIns="27432" bIns="27432">
+            <a:spAutoFit/>
+          </a:bodyPr>
+          <a:lstStyle/>
+          <a:p>
+            <a:pPr algn="ctr"/>
+            <a:r>
+              <a:rPr sz="900" b="0" i="0">
+                <a:solidFill>
+                  <a:srgbClr val="9AA7B5"/>
+                </a:solidFill>
+                <a:latin typeface="Calibri"/>
+              </a:rPr>
+              <a:t>W2</a:t>
+            </a:r>
+          </a:p>
+        </p:txBody>
+      </p:sp>
+      <p:sp>
+        <p:nvSpPr>
+          <p:cNvPr id="9" name="Rectangle 8"/>
+          <p:cNvSpPr/>
+          <p:nvPr/>
+        </p:nvSpPr>
+        <p:spPr>
+          <a:xfrm>
+            <a:off x="5829300" y="1618487"/>
+            <a:ext cx="10972" cy="3657600"/>
+          </a:xfrm>
+          <a:prstGeom prst="rect">
+            <a:avLst/>
+          </a:prstGeom>
+          <a:solidFill>
+            <a:srgbClr val="E6ECF3"/>
+          </a:solidFill>
+          <a:ln>
+            <a:noFill/>
+          </a:ln>
+          <a:effectLst/>
+        </p:spPr>
+        <p:style>
+          <a:lnRef idx="1">
+            <a:schemeClr val="accent1"/>
+          </a:lnRef>
+          <a:fillRef idx="3">
+            <a:schemeClr val="accent1"/>
+          </a:fillRef>
+          <a:effectRef idx="2">
+            <a:schemeClr val="accent1"/>
+          </a:effectRef>
+          <a:fontRef idx="minor">
+            <a:schemeClr val="lt1"/>
+          </a:fontRef>
+        </p:style>
+        <p:txBody>
+          <a:bodyPr rtlCol="0" anchor="ctr"/>
+          <a:lstStyle/>
+          <a:p>
+            <a:pPr algn="ctr"/>
+          </a:p>
+        </p:txBody>
+      </p:sp>
+      <p:sp>
+        <p:nvSpPr>
+          <p:cNvPr id="10" name="TextBox 9"/>
+          <p:cNvSpPr txBox="1"/>
+          <p:nvPr/>
+        </p:nvSpPr>
+        <p:spPr>
+          <a:xfrm>
+            <a:off x="5646420" y="1581911"/>
+            <a:ext cx="365760" cy="228600"/>
+          </a:xfrm>
+          <a:prstGeom prst="rect">
+            <a:avLst/>
+          </a:prstGeom>
+          <a:noFill/>
+        </p:spPr>
+        <p:txBody>
+          <a:bodyPr wrap="square" anchor="t" lIns="27432" rIns="27432" tIns="27432" bIns="27432">
+            <a:spAutoFit/>
+          </a:bodyPr>
+          <a:lstStyle/>
+          <a:p>
+            <a:pPr algn="ctr"/>
+            <a:r>
+              <a:rPr sz="900" b="0" i="0">
+                <a:solidFill>
+                  <a:srgbClr val="9AA7B5"/>
+                </a:solidFill>
+                <a:latin typeface="Calibri"/>
+              </a:rPr>
+              <a:t>W4</a:t>
+            </a:r>
+          </a:p>
+        </p:txBody>
+      </p:sp>
+      <p:sp>
+        <p:nvSpPr>
+          <p:cNvPr id="11" name="Rectangle 10"/>
+          <p:cNvSpPr/>
+          <p:nvPr/>
+        </p:nvSpPr>
+        <p:spPr>
+          <a:xfrm>
+            <a:off x="6755129" y="1618487"/>
+            <a:ext cx="10972" cy="3657600"/>
+          </a:xfrm>
+          <a:prstGeom prst="rect">
+            <a:avLst/>
+          </a:prstGeom>
+          <a:solidFill>
+            <a:srgbClr val="E6ECF3"/>
+          </a:solidFill>
+          <a:ln>
+            <a:noFill/>
+          </a:ln>
+          <a:effectLst/>
+        </p:spPr>
+        <p:style>
+          <a:lnRef idx="1">
+            <a:schemeClr val="accent1"/>
+          </a:lnRef>
+          <a:fillRef idx="3">
+            <a:schemeClr val="accent1"/>
+          </a:fillRef>
+          <a:effectRef idx="2">
+            <a:schemeClr val="accent1"/>
+          </a:effectRef>
+          <a:fontRef idx="minor">
+            <a:schemeClr val="lt1"/>
+          </a:fontRef>
+        </p:style>
+        <p:txBody>
+          <a:bodyPr rtlCol="0" anchor="ctr"/>
+          <a:lstStyle/>
+          <a:p>
+            <a:pPr algn="ctr"/>
+          </a:p>
+        </p:txBody>
+      </p:sp>
+      <p:sp>
+        <p:nvSpPr>
+          <p:cNvPr id="12" name="TextBox 11"/>
+          <p:cNvSpPr txBox="1"/>
+          <p:nvPr/>
+        </p:nvSpPr>
+        <p:spPr>
+          <a:xfrm>
+            <a:off x="6572249" y="1581911"/>
+            <a:ext cx="365760" cy="228600"/>
+          </a:xfrm>
+          <a:prstGeom prst="rect">
+            <a:avLst/>
+          </a:prstGeom>
+          <a:noFill/>
+        </p:spPr>
+        <p:txBody>
+          <a:bodyPr wrap="square" anchor="t" lIns="27432" rIns="27432" tIns="27432" bIns="27432">
+            <a:spAutoFit/>
+          </a:bodyPr>
+          <a:lstStyle/>
+          <a:p>
+            <a:pPr algn="ctr"/>
+            <a:r>
+              <a:rPr sz="900" b="0" i="0">
+                <a:solidFill>
+                  <a:srgbClr val="9AA7B5"/>
+                </a:solidFill>
+                <a:latin typeface="Calibri"/>
+              </a:rPr>
+              <a:t>W6</a:t>
+            </a:r>
+          </a:p>
+        </p:txBody>
+      </p:sp>
+      <p:sp>
+        <p:nvSpPr>
+          <p:cNvPr id="13" name="Rectangle 12"/>
+          <p:cNvSpPr/>
+          <p:nvPr/>
+        </p:nvSpPr>
+        <p:spPr>
+          <a:xfrm>
+            <a:off x="7680959" y="1618487"/>
+            <a:ext cx="10972" cy="3657600"/>
+          </a:xfrm>
+          <a:prstGeom prst="rect">
+            <a:avLst/>
+          </a:prstGeom>
+          <a:solidFill>
+            <a:srgbClr val="E6ECF3"/>
+          </a:solidFill>
+          <a:ln>
+            <a:noFill/>
+          </a:ln>
+          <a:effectLst/>
+        </p:spPr>
+        <p:style>
+          <a:lnRef idx="1">
+            <a:schemeClr val="accent1"/>
+          </a:lnRef>
+          <a:fillRef idx="3">
+            <a:schemeClr val="accent1"/>
+          </a:fillRef>
+          <a:effectRef idx="2">
+            <a:schemeClr val="accent1"/>
+          </a:effectRef>
+          <a:fontRef idx="minor">
+            <a:schemeClr val="lt1"/>
+          </a:fontRef>
+        </p:style>
+        <p:txBody>
+          <a:bodyPr rtlCol="0" anchor="ctr"/>
+          <a:lstStyle/>
+          <a:p>
+            <a:pPr algn="ctr"/>
+          </a:p>
+        </p:txBody>
+      </p:sp>
+      <p:sp>
+        <p:nvSpPr>
+          <p:cNvPr id="14" name="TextBox 13"/>
+          <p:cNvSpPr txBox="1"/>
+          <p:nvPr/>
+        </p:nvSpPr>
+        <p:spPr>
+          <a:xfrm>
+            <a:off x="7498079" y="1581911"/>
+            <a:ext cx="365760" cy="228600"/>
+          </a:xfrm>
+          <a:prstGeom prst="rect">
+            <a:avLst/>
+          </a:prstGeom>
+          <a:noFill/>
+        </p:spPr>
+        <p:txBody>
+          <a:bodyPr wrap="square" anchor="t" lIns="27432" rIns="27432" tIns="27432" bIns="27432">
+            <a:spAutoFit/>
+          </a:bodyPr>
+          <a:lstStyle/>
+          <a:p>
+            <a:pPr algn="ctr"/>
+            <a:r>
+              <a:rPr sz="900" b="0" i="0">
+                <a:solidFill>
+                  <a:srgbClr val="9AA7B5"/>
+                </a:solidFill>
+                <a:latin typeface="Calibri"/>
+              </a:rPr>
+              <a:t>W8</a:t>
+            </a:r>
+          </a:p>
+        </p:txBody>
+      </p:sp>
+      <p:sp>
+        <p:nvSpPr>
+          <p:cNvPr id="15" name="Rectangle 14"/>
+          <p:cNvSpPr/>
+          <p:nvPr/>
+        </p:nvSpPr>
+        <p:spPr>
+          <a:xfrm>
+            <a:off x="8606790" y="1618487"/>
+            <a:ext cx="10972" cy="3657600"/>
+          </a:xfrm>
+          <a:prstGeom prst="rect">
+            <a:avLst/>
+          </a:prstGeom>
+          <a:solidFill>
+            <a:srgbClr val="E6ECF3"/>
+          </a:solidFill>
+          <a:ln>
+            <a:noFill/>
+          </a:ln>
+          <a:effectLst/>
+        </p:spPr>
+        <p:style>
+          <a:lnRef idx="1">
+            <a:schemeClr val="accent1"/>
+          </a:lnRef>
+          <a:fillRef idx="3">
+            <a:schemeClr val="accent1"/>
+          </a:fillRef>
+          <a:effectRef idx="2">
+            <a:schemeClr val="accent1"/>
+          </a:effectRef>
+          <a:fontRef idx="minor">
+            <a:schemeClr val="lt1"/>
+          </a:fontRef>
+        </p:style>
+        <p:txBody>
+          <a:bodyPr rtlCol="0" anchor="ctr"/>
+          <a:lstStyle/>
+          <a:p>
+            <a:pPr algn="ctr"/>
+          </a:p>
+        </p:txBody>
+      </p:sp>
+      <p:sp>
+        <p:nvSpPr>
+          <p:cNvPr id="16" name="TextBox 15"/>
+          <p:cNvSpPr txBox="1"/>
+          <p:nvPr/>
+        </p:nvSpPr>
+        <p:spPr>
+          <a:xfrm>
+            <a:off x="8423910" y="1581911"/>
+            <a:ext cx="365760" cy="228600"/>
+          </a:xfrm>
+          <a:prstGeom prst="rect">
+            <a:avLst/>
+          </a:prstGeom>
+          <a:noFill/>
+        </p:spPr>
+        <p:txBody>
+          <a:bodyPr wrap="square" anchor="t" lIns="27432" rIns="27432" tIns="27432" bIns="27432">
+            <a:spAutoFit/>
+          </a:bodyPr>
+          <a:lstStyle/>
+          <a:p>
+            <a:pPr algn="ctr"/>
+            <a:r>
+              <a:rPr sz="900" b="0" i="0">
+                <a:solidFill>
+                  <a:srgbClr val="9AA7B5"/>
+                </a:solidFill>
+                <a:latin typeface="Calibri"/>
+              </a:rPr>
+              <a:t>W10</a:t>
+            </a:r>
+          </a:p>
+        </p:txBody>
+      </p:sp>
+      <p:sp>
+        <p:nvSpPr>
+          <p:cNvPr id="17" name="Rectangle 16"/>
+          <p:cNvSpPr/>
+          <p:nvPr/>
+        </p:nvSpPr>
+        <p:spPr>
+          <a:xfrm>
+            <a:off x="9532619" y="1618487"/>
+            <a:ext cx="10972" cy="3657600"/>
+          </a:xfrm>
+          <a:prstGeom prst="rect">
+            <a:avLst/>
+          </a:prstGeom>
+          <a:solidFill>
+            <a:srgbClr val="E6ECF3"/>
+          </a:solidFill>
+          <a:ln>
+            <a:noFill/>
+          </a:ln>
+          <a:effectLst/>
+        </p:spPr>
+        <p:style>
+          <a:lnRef idx="1">
+            <a:schemeClr val="accent1"/>
+          </a:lnRef>
+          <a:fillRef idx="3">
+            <a:schemeClr val="accent1"/>
+          </a:fillRef>
+          <a:effectRef idx="2">
+            <a:schemeClr val="accent1"/>
+          </a:effectRef>
+          <a:fontRef idx="minor">
+            <a:schemeClr val="lt1"/>
+          </a:fontRef>
+        </p:style>
+        <p:txBody>
+          <a:bodyPr rtlCol="0" anchor="ctr"/>
+          <a:lstStyle/>
+          <a:p>
+            <a:pPr algn="ctr"/>
+          </a:p>
+        </p:txBody>
+      </p:sp>
+      <p:sp>
+        <p:nvSpPr>
+          <p:cNvPr id="18" name="TextBox 17"/>
+          <p:cNvSpPr txBox="1"/>
+          <p:nvPr/>
+        </p:nvSpPr>
+        <p:spPr>
+          <a:xfrm>
+            <a:off x="9349740" y="1581911"/>
+            <a:ext cx="365760" cy="228600"/>
+          </a:xfrm>
+          <a:prstGeom prst="rect">
+            <a:avLst/>
+          </a:prstGeom>
+          <a:noFill/>
+        </p:spPr>
+        <p:txBody>
+          <a:bodyPr wrap="square" anchor="t" lIns="27432" rIns="27432" tIns="27432" bIns="27432">
+            <a:spAutoFit/>
+          </a:bodyPr>
+          <a:lstStyle/>
+          <a:p>
+            <a:pPr algn="ctr"/>
+            <a:r>
+              <a:rPr sz="900" b="0" i="0">
+                <a:solidFill>
+                  <a:srgbClr val="9AA7B5"/>
+                </a:solidFill>
+                <a:latin typeface="Calibri"/>
+              </a:rPr>
+              <a:t>W12</a:t>
+            </a:r>
+          </a:p>
+        </p:txBody>
+      </p:sp>
+      <p:sp>
+        <p:nvSpPr>
+          <p:cNvPr id="19" name="Rectangle 18"/>
+          <p:cNvSpPr/>
+          <p:nvPr/>
+        </p:nvSpPr>
+        <p:spPr>
+          <a:xfrm>
+            <a:off x="10458450" y="1618487"/>
+            <a:ext cx="10972" cy="3657600"/>
+          </a:xfrm>
+          <a:prstGeom prst="rect">
+            <a:avLst/>
+          </a:prstGeom>
+          <a:solidFill>
+            <a:srgbClr val="E6ECF3"/>
+          </a:solidFill>
+          <a:ln>
+            <a:noFill/>
+          </a:ln>
+          <a:effectLst/>
+        </p:spPr>
+        <p:style>
+          <a:lnRef idx="1">
+            <a:schemeClr val="accent1"/>
+          </a:lnRef>
+          <a:fillRef idx="3">
+            <a:schemeClr val="accent1"/>
+          </a:fillRef>
+          <a:effectRef idx="2">
+            <a:schemeClr val="accent1"/>
+          </a:effectRef>
+          <a:fontRef idx="minor">
+            <a:schemeClr val="lt1"/>
+          </a:fontRef>
+        </p:style>
+        <p:txBody>
+          <a:bodyPr rtlCol="0" anchor="ctr"/>
+          <a:lstStyle/>
+          <a:p>
+            <a:pPr algn="ctr"/>
+          </a:p>
+        </p:txBody>
+      </p:sp>
+      <p:sp>
+        <p:nvSpPr>
+          <p:cNvPr id="20" name="TextBox 19"/>
+          <p:cNvSpPr txBox="1"/>
+          <p:nvPr/>
+        </p:nvSpPr>
+        <p:spPr>
+          <a:xfrm>
+            <a:off x="10275570" y="1581911"/>
+            <a:ext cx="365760" cy="228600"/>
+          </a:xfrm>
+          <a:prstGeom prst="rect">
+            <a:avLst/>
+          </a:prstGeom>
+          <a:noFill/>
+        </p:spPr>
+        <p:txBody>
+          <a:bodyPr wrap="square" anchor="t" lIns="27432" rIns="27432" tIns="27432" bIns="27432">
+            <a:spAutoFit/>
+          </a:bodyPr>
+          <a:lstStyle/>
+          <a:p>
+            <a:pPr algn="ctr"/>
+            <a:r>
+              <a:rPr sz="900" b="0" i="0">
+                <a:solidFill>
+                  <a:srgbClr val="9AA7B5"/>
+                </a:solidFill>
+                <a:latin typeface="Calibri"/>
+              </a:rPr>
+              <a:t>W14</a:t>
+            </a:r>
+          </a:p>
+        </p:txBody>
+      </p:sp>
+      <p:sp>
+        <p:nvSpPr>
+          <p:cNvPr id="21" name="Rectangle 20"/>
+          <p:cNvSpPr/>
+          <p:nvPr/>
+        </p:nvSpPr>
+        <p:spPr>
+          <a:xfrm>
+            <a:off x="11384280" y="1618487"/>
+            <a:ext cx="10972" cy="3657600"/>
+          </a:xfrm>
+          <a:prstGeom prst="rect">
+            <a:avLst/>
+          </a:prstGeom>
+          <a:solidFill>
+            <a:srgbClr val="E6ECF3"/>
+          </a:solidFill>
+          <a:ln>
+            <a:noFill/>
+          </a:ln>
+          <a:effectLst/>
+        </p:spPr>
+        <p:style>
+          <a:lnRef idx="1">
+            <a:schemeClr val="accent1"/>
+          </a:lnRef>
+          <a:fillRef idx="3">
+            <a:schemeClr val="accent1"/>
+          </a:fillRef>
+          <a:effectRef idx="2">
+            <a:schemeClr val="accent1"/>
+          </a:effectRef>
+          <a:fontRef idx="minor">
+            <a:schemeClr val="lt1"/>
+          </a:fontRef>
+        </p:style>
+        <p:txBody>
+          <a:bodyPr rtlCol="0" anchor="ctr"/>
+          <a:lstStyle/>
+          <a:p>
+            <a:pPr algn="ctr"/>
+          </a:p>
+        </p:txBody>
+      </p:sp>
+      <p:sp>
+        <p:nvSpPr>
+          <p:cNvPr id="22" name="TextBox 21"/>
+          <p:cNvSpPr txBox="1"/>
+          <p:nvPr/>
+        </p:nvSpPr>
+        <p:spPr>
+          <a:xfrm>
+            <a:off x="11201400" y="1581911"/>
+            <a:ext cx="365760" cy="228600"/>
+          </a:xfrm>
+          <a:prstGeom prst="rect">
+            <a:avLst/>
+          </a:prstGeom>
+          <a:noFill/>
+        </p:spPr>
+        <p:txBody>
+          <a:bodyPr wrap="square" anchor="t" lIns="27432" rIns="27432" tIns="27432" bIns="27432">
+            <a:spAutoFit/>
+          </a:bodyPr>
+          <a:lstStyle/>
+          <a:p>
+            <a:pPr algn="ctr"/>
+            <a:r>
+              <a:rPr sz="900" b="0" i="0">
+                <a:solidFill>
+                  <a:srgbClr val="9AA7B5"/>
+                </a:solidFill>
+                <a:latin typeface="Calibri"/>
+              </a:rPr>
+              <a:t>W16</a:t>
+            </a:r>
+          </a:p>
+        </p:txBody>
+      </p:sp>
+      <p:sp>
+        <p:nvSpPr>
+          <p:cNvPr id="23" name="TextBox 22"/>
+          <p:cNvSpPr txBox="1"/>
+          <p:nvPr/>
+        </p:nvSpPr>
+        <p:spPr>
+          <a:xfrm>
+            <a:off x="749808" y="1874519"/>
+            <a:ext cx="3108960" cy="475488"/>
+          </a:xfrm>
+          <a:prstGeom prst="rect">
+            <a:avLst/>
+          </a:prstGeom>
+          <a:noFill/>
+        </p:spPr>
+        <p:txBody>
+          <a:bodyPr wrap="square" anchor="ctr" lIns="27432" rIns="27432" tIns="27432" bIns="27432">
+            <a:spAutoFit/>
+          </a:bodyPr>
+          <a:lstStyle/>
+          <a:p>
+            <a:pPr algn="l">
+              <a:spcAft>
+                <a:spcPts val="100"/>
+              </a:spcAft>
+            </a:pPr>
+            <a:r>
+              <a:rPr sz="1150" b="1" i="0">
+                <a:solidFill>
+                  <a:srgbClr val="0A1A33"/>
+                </a:solidFill>
+                <a:latin typeface="Calibri"/>
+              </a:rPr>
+              <a:t>Phase 1 · Research &amp; Planning</a:t>
+            </a:r>
+          </a:p>
+          <a:p>
+            <a:pPr algn="l"/>
+            <a:r>
+              <a:rPr sz="900" b="0" i="0">
+                <a:solidFill>
+                  <a:srgbClr val="5B6B82"/>
+                </a:solidFill>
+                <a:latin typeface="Calibri"/>
+              </a:rPr>
+              <a:t>Literature review · dataset prep · environment setup</a:t>
+            </a:r>
+          </a:p>
+        </p:txBody>
+      </p:sp>
+      <p:sp>
+        <p:nvSpPr>
+          <p:cNvPr id="24" name="Rounded Rectangle 23"/>
+          <p:cNvSpPr/>
+          <p:nvPr/>
+        </p:nvSpPr>
+        <p:spPr>
+          <a:xfrm>
+            <a:off x="3977639" y="1929384"/>
+            <a:ext cx="1388744" cy="365760"/>
+          </a:xfrm>
+          <a:prstGeom prst="roundRect">
+            <a:avLst/>
+          </a:prstGeom>
+          <a:solidFill>
+            <a:srgbClr val="1FBFAE"/>
+          </a:solidFill>
+          <a:ln>
+            <a:noFill/>
+          </a:ln>
+          <a:effectLst/>
+        </p:spPr>
+        <p:style>
+          <a:lnRef idx="1">
+            <a:schemeClr val="accent1"/>
+          </a:lnRef>
+          <a:fillRef idx="3">
+            <a:schemeClr val="accent1"/>
+          </a:fillRef>
+          <a:effectRef idx="2">
+            <a:schemeClr val="accent1"/>
+          </a:effectRef>
+          <a:fontRef idx="minor">
+            <a:schemeClr val="lt1"/>
+          </a:fontRef>
+        </p:style>
+        <p:txBody>
+          <a:bodyPr rtlCol="0" anchor="ctr"/>
+          <a:lstStyle/>
+          <a:p>
+            <a:pPr algn="ctr"/>
+          </a:p>
+        </p:txBody>
+      </p:sp>
+      <p:sp>
+        <p:nvSpPr>
+          <p:cNvPr id="25" name="TextBox 24"/>
+          <p:cNvSpPr txBox="1"/>
+          <p:nvPr/>
+        </p:nvSpPr>
+        <p:spPr>
+          <a:xfrm>
+            <a:off x="3977639" y="1929384"/>
+            <a:ext cx="1388744" cy="365760"/>
+          </a:xfrm>
+          <a:prstGeom prst="rect">
+            <a:avLst/>
+          </a:prstGeom>
+          <a:noFill/>
+        </p:spPr>
+        <p:txBody>
+          <a:bodyPr wrap="square" anchor="ctr" lIns="27432" rIns="27432" tIns="27432" bIns="27432">
+            <a:spAutoFit/>
+          </a:bodyPr>
+          <a:lstStyle/>
+          <a:p>
+            <a:pPr algn="ctr"/>
+            <a:r>
+              <a:rPr sz="1000" b="1" i="0">
+                <a:solidFill>
+                  <a:srgbClr val="FFFFFF"/>
+                </a:solidFill>
+                <a:latin typeface="Calibri"/>
+              </a:rPr>
+              <a:t>3 wks</a:t>
+            </a:r>
+          </a:p>
+        </p:txBody>
+      </p:sp>
+      <p:sp>
+        <p:nvSpPr>
+          <p:cNvPr id="26" name="TextBox 25"/>
+          <p:cNvSpPr txBox="1"/>
+          <p:nvPr/>
+        </p:nvSpPr>
+        <p:spPr>
+          <a:xfrm>
+            <a:off x="749808" y="2459736"/>
+            <a:ext cx="3108960" cy="475488"/>
+          </a:xfrm>
+          <a:prstGeom prst="rect">
+            <a:avLst/>
+          </a:prstGeom>
+          <a:noFill/>
+        </p:spPr>
+        <p:txBody>
+          <a:bodyPr wrap="square" anchor="ctr" lIns="27432" rIns="27432" tIns="27432" bIns="27432">
+            <a:spAutoFit/>
+          </a:bodyPr>
+          <a:lstStyle/>
+          <a:p>
+            <a:pPr algn="l">
+              <a:spcAft>
+                <a:spcPts val="100"/>
+              </a:spcAft>
+            </a:pPr>
+            <a:r>
+              <a:rPr sz="1150" b="1" i="0">
+                <a:solidFill>
+                  <a:srgbClr val="0A1A33"/>
+                </a:solidFill>
+                <a:latin typeface="Calibri"/>
+              </a:rPr>
+              <a:t>Phase 2 · Individual Models</a:t>
+            </a:r>
+          </a:p>
+          <a:p>
+            <a:pPr algn="l"/>
+            <a:r>
+              <a:rPr sz="900" b="0" i="0">
+                <a:solidFill>
+                  <a:srgbClr val="5B6B82"/>
+                </a:solidFill>
+                <a:latin typeface="Calibri"/>
+              </a:rPr>
+              <a:t>CNN · classical ML · pretrained fine-tuning</a:t>
+            </a:r>
+          </a:p>
+        </p:txBody>
+      </p:sp>
+      <p:sp>
+        <p:nvSpPr>
+          <p:cNvPr id="27" name="Rounded Rectangle 26"/>
+          <p:cNvSpPr/>
+          <p:nvPr/>
+        </p:nvSpPr>
+        <p:spPr>
+          <a:xfrm>
+            <a:off x="5366384" y="2514600"/>
+            <a:ext cx="1851660" cy="365760"/>
+          </a:xfrm>
+          <a:prstGeom prst="roundRect">
+            <a:avLst/>
+          </a:prstGeom>
+          <a:solidFill>
+            <a:srgbClr val="0E7C72"/>
+          </a:solidFill>
+          <a:ln>
+            <a:noFill/>
+          </a:ln>
+          <a:effectLst/>
+        </p:spPr>
+        <p:style>
+          <a:lnRef idx="1">
+            <a:schemeClr val="accent1"/>
+          </a:lnRef>
+          <a:fillRef idx="3">
+            <a:schemeClr val="accent1"/>
+          </a:fillRef>
+          <a:effectRef idx="2">
+            <a:schemeClr val="accent1"/>
+          </a:effectRef>
+          <a:fontRef idx="minor">
+            <a:schemeClr val="lt1"/>
+          </a:fontRef>
+        </p:style>
+        <p:txBody>
+          <a:bodyPr rtlCol="0" anchor="ctr"/>
+          <a:lstStyle/>
+          <a:p>
+            <a:pPr algn="ctr"/>
+          </a:p>
+        </p:txBody>
+      </p:sp>
+      <p:sp>
+        <p:nvSpPr>
+          <p:cNvPr id="28" name="TextBox 27"/>
+          <p:cNvSpPr txBox="1"/>
+          <p:nvPr/>
+        </p:nvSpPr>
+        <p:spPr>
+          <a:xfrm>
+            <a:off x="5366384" y="2514600"/>
+            <a:ext cx="1851660" cy="365760"/>
+          </a:xfrm>
+          <a:prstGeom prst="rect">
+            <a:avLst/>
+          </a:prstGeom>
+          <a:noFill/>
+        </p:spPr>
+        <p:txBody>
+          <a:bodyPr wrap="square" anchor="ctr" lIns="27432" rIns="27432" tIns="27432" bIns="27432">
+            <a:spAutoFit/>
+          </a:bodyPr>
+          <a:lstStyle/>
+          <a:p>
+            <a:pPr algn="ctr"/>
+            <a:r>
+              <a:rPr sz="1000" b="1" i="0">
+                <a:solidFill>
+                  <a:srgbClr val="FFFFFF"/>
+                </a:solidFill>
+                <a:latin typeface="Calibri"/>
+              </a:rPr>
+              <a:t>4 wks</a:t>
+            </a:r>
+          </a:p>
+        </p:txBody>
+      </p:sp>
+      <p:sp>
+        <p:nvSpPr>
+          <p:cNvPr id="29" name="TextBox 28"/>
+          <p:cNvSpPr txBox="1"/>
+          <p:nvPr/>
+        </p:nvSpPr>
+        <p:spPr>
+          <a:xfrm>
+            <a:off x="749808" y="3044952"/>
+            <a:ext cx="3108960" cy="475488"/>
+          </a:xfrm>
+          <a:prstGeom prst="rect">
+            <a:avLst/>
+          </a:prstGeom>
+          <a:noFill/>
+        </p:spPr>
+        <p:txBody>
+          <a:bodyPr wrap="square" anchor="ctr" lIns="27432" rIns="27432" tIns="27432" bIns="27432">
+            <a:spAutoFit/>
+          </a:bodyPr>
+          <a:lstStyle/>
+          <a:p>
+            <a:pPr algn="l">
+              <a:spcAft>
+                <a:spcPts val="100"/>
+              </a:spcAft>
+            </a:pPr>
+            <a:r>
+              <a:rPr sz="1150" b="1" i="0">
+                <a:solidFill>
+                  <a:srgbClr val="0A1A33"/>
+                </a:solidFill>
+                <a:latin typeface="Calibri"/>
+              </a:rPr>
+              <a:t>Phase 3 · Ensemble Framework</a:t>
+            </a:r>
+          </a:p>
+          <a:p>
+            <a:pPr algn="l"/>
+            <a:r>
+              <a:rPr sz="900" b="0" i="0">
+                <a:solidFill>
+                  <a:srgbClr val="5B6B82"/>
+                </a:solidFill>
+                <a:latin typeface="Calibri"/>
+              </a:rPr>
+              <a:t>Architecture · integration · optimisation</a:t>
+            </a:r>
+          </a:p>
+        </p:txBody>
+      </p:sp>
+      <p:sp>
+        <p:nvSpPr>
+          <p:cNvPr id="30" name="Rounded Rectangle 29"/>
+          <p:cNvSpPr/>
+          <p:nvPr/>
+        </p:nvSpPr>
+        <p:spPr>
+          <a:xfrm>
+            <a:off x="7218044" y="3099816"/>
+            <a:ext cx="1388744" cy="365760"/>
+          </a:xfrm>
+          <a:prstGeom prst="roundRect">
+            <a:avLst/>
+          </a:prstGeom>
+          <a:solidFill>
+            <a:srgbClr val="1FBFAE"/>
+          </a:solidFill>
+          <a:ln>
+            <a:noFill/>
+          </a:ln>
+          <a:effectLst/>
+        </p:spPr>
+        <p:style>
+          <a:lnRef idx="1">
+            <a:schemeClr val="accent1"/>
+          </a:lnRef>
+          <a:fillRef idx="3">
+            <a:schemeClr val="accent1"/>
+          </a:fillRef>
+          <a:effectRef idx="2">
+            <a:schemeClr val="accent1"/>
+          </a:effectRef>
+          <a:fontRef idx="minor">
+            <a:schemeClr val="lt1"/>
+          </a:fontRef>
+        </p:style>
+        <p:txBody>
+          <a:bodyPr rtlCol="0" anchor="ctr"/>
+          <a:lstStyle/>
+          <a:p>
+            <a:pPr algn="ctr"/>
+          </a:p>
+        </p:txBody>
+      </p:sp>
+      <p:sp>
+        <p:nvSpPr>
+          <p:cNvPr id="31" name="TextBox 30"/>
+          <p:cNvSpPr txBox="1"/>
+          <p:nvPr/>
+        </p:nvSpPr>
+        <p:spPr>
+          <a:xfrm>
+            <a:off x="7218044" y="3099816"/>
+            <a:ext cx="1388744" cy="365760"/>
+          </a:xfrm>
+          <a:prstGeom prst="rect">
+            <a:avLst/>
+          </a:prstGeom>
+          <a:noFill/>
+        </p:spPr>
+        <p:txBody>
+          <a:bodyPr wrap="square" anchor="ctr" lIns="27432" rIns="27432" tIns="27432" bIns="27432">
+            <a:spAutoFit/>
+          </a:bodyPr>
+          <a:lstStyle/>
+          <a:p>
+            <a:pPr algn="ctr"/>
+            <a:r>
+              <a:rPr sz="1000" b="1" i="0">
+                <a:solidFill>
+                  <a:srgbClr val="FFFFFF"/>
+                </a:solidFill>
+                <a:latin typeface="Calibri"/>
+              </a:rPr>
+              <a:t>3 wks</a:t>
+            </a:r>
+          </a:p>
+        </p:txBody>
+      </p:sp>
+      <p:sp>
+        <p:nvSpPr>
+          <p:cNvPr id="32" name="TextBox 31"/>
+          <p:cNvSpPr txBox="1"/>
+          <p:nvPr/>
+        </p:nvSpPr>
+        <p:spPr>
+          <a:xfrm>
+            <a:off x="749808" y="3630168"/>
+            <a:ext cx="3108960" cy="475488"/>
+          </a:xfrm>
+          <a:prstGeom prst="rect">
+            <a:avLst/>
+          </a:prstGeom>
+          <a:noFill/>
+        </p:spPr>
+        <p:txBody>
+          <a:bodyPr wrap="square" anchor="ctr" lIns="27432" rIns="27432" tIns="27432" bIns="27432">
+            <a:spAutoFit/>
+          </a:bodyPr>
+          <a:lstStyle/>
+          <a:p>
+            <a:pPr algn="l">
+              <a:spcAft>
+                <a:spcPts val="100"/>
+              </a:spcAft>
+            </a:pPr>
+            <a:r>
+              <a:rPr sz="1150" b="1" i="0">
+                <a:solidFill>
+                  <a:srgbClr val="0A1A33"/>
+                </a:solidFill>
+                <a:latin typeface="Calibri"/>
+              </a:rPr>
+              <a:t>Phase 4 · Performance Evaluation</a:t>
+            </a:r>
+          </a:p>
+          <a:p>
+            <a:pPr algn="l"/>
+            <a:r>
+              <a:rPr sz="900" b="0" i="0">
+                <a:solidFill>
+                  <a:srgbClr val="5B6B82"/>
+                </a:solidFill>
+                <a:latin typeface="Calibri"/>
+              </a:rPr>
+              <a:t>Testing · statistical analysis · results</a:t>
+            </a:r>
+          </a:p>
+        </p:txBody>
+      </p:sp>
+      <p:sp>
+        <p:nvSpPr>
+          <p:cNvPr id="33" name="Rounded Rectangle 32"/>
+          <p:cNvSpPr/>
+          <p:nvPr/>
+        </p:nvSpPr>
+        <p:spPr>
+          <a:xfrm>
+            <a:off x="8606790" y="3685031"/>
+            <a:ext cx="925830" cy="365760"/>
+          </a:xfrm>
+          <a:prstGeom prst="roundRect">
+            <a:avLst/>
+          </a:prstGeom>
+          <a:solidFill>
+            <a:srgbClr val="0E7C72"/>
+          </a:solidFill>
+          <a:ln>
+            <a:noFill/>
+          </a:ln>
+          <a:effectLst/>
+        </p:spPr>
+        <p:style>
+          <a:lnRef idx="1">
+            <a:schemeClr val="accent1"/>
+          </a:lnRef>
+          <a:fillRef idx="3">
+            <a:schemeClr val="accent1"/>
+          </a:fillRef>
+          <a:effectRef idx="2">
+            <a:schemeClr val="accent1"/>
+          </a:effectRef>
+          <a:fontRef idx="minor">
+            <a:schemeClr val="lt1"/>
+          </a:fontRef>
+        </p:style>
+        <p:txBody>
+          <a:bodyPr rtlCol="0" anchor="ctr"/>
+          <a:lstStyle/>
+          <a:p>
+            <a:pPr algn="ctr"/>
+          </a:p>
+        </p:txBody>
+      </p:sp>
+      <p:sp>
+        <p:nvSpPr>
+          <p:cNvPr id="34" name="TextBox 33"/>
+          <p:cNvSpPr txBox="1"/>
+          <p:nvPr/>
+        </p:nvSpPr>
+        <p:spPr>
+          <a:xfrm>
+            <a:off x="8606790" y="3685031"/>
+            <a:ext cx="925830" cy="365760"/>
+          </a:xfrm>
+          <a:prstGeom prst="rect">
+            <a:avLst/>
+          </a:prstGeom>
+          <a:noFill/>
+        </p:spPr>
+        <p:txBody>
+          <a:bodyPr wrap="square" anchor="ctr" lIns="27432" rIns="27432" tIns="27432" bIns="27432">
+            <a:spAutoFit/>
+          </a:bodyPr>
+          <a:lstStyle/>
+          <a:p>
+            <a:pPr algn="ctr"/>
+            <a:r>
+              <a:rPr sz="1000" b="1" i="0">
+                <a:solidFill>
+                  <a:srgbClr val="FFFFFF"/>
+                </a:solidFill>
+                <a:latin typeface="Calibri"/>
+              </a:rPr>
+              <a:t>2 wks</a:t>
+            </a:r>
+          </a:p>
+        </p:txBody>
+      </p:sp>
+      <p:sp>
+        <p:nvSpPr>
+          <p:cNvPr id="35" name="TextBox 34"/>
+          <p:cNvSpPr txBox="1"/>
+          <p:nvPr/>
+        </p:nvSpPr>
+        <p:spPr>
+          <a:xfrm>
+            <a:off x="749808" y="4215383"/>
+            <a:ext cx="3108960" cy="475488"/>
+          </a:xfrm>
+          <a:prstGeom prst="rect">
+            <a:avLst/>
+          </a:prstGeom>
+          <a:noFill/>
+        </p:spPr>
+        <p:txBody>
+          <a:bodyPr wrap="square" anchor="ctr" lIns="27432" rIns="27432" tIns="27432" bIns="27432">
+            <a:spAutoFit/>
+          </a:bodyPr>
+          <a:lstStyle/>
+          <a:p>
+            <a:pPr algn="l">
+              <a:spcAft>
+                <a:spcPts val="100"/>
+              </a:spcAft>
+            </a:pPr>
+            <a:r>
+              <a:rPr sz="1150" b="1" i="0">
+                <a:solidFill>
+                  <a:srgbClr val="0A1A33"/>
+                </a:solidFill>
+                <a:latin typeface="Calibri"/>
+              </a:rPr>
+              <a:t>Phase 5 · Application Development</a:t>
+            </a:r>
+          </a:p>
+          <a:p>
+            <a:pPr algn="l"/>
+            <a:r>
+              <a:rPr sz="900" b="0" i="0">
+                <a:solidFill>
+                  <a:srgbClr val="5B6B82"/>
+                </a:solidFill>
+                <a:latin typeface="Calibri"/>
+              </a:rPr>
+              <a:t>Web interface · UX · XAI integration</a:t>
+            </a:r>
+          </a:p>
+        </p:txBody>
+      </p:sp>
+      <p:sp>
+        <p:nvSpPr>
+          <p:cNvPr id="36" name="Rounded Rectangle 35"/>
+          <p:cNvSpPr/>
+          <p:nvPr/>
+        </p:nvSpPr>
+        <p:spPr>
+          <a:xfrm>
+            <a:off x="9532619" y="4270247"/>
+            <a:ext cx="925830" cy="365760"/>
+          </a:xfrm>
+          <a:prstGeom prst="roundRect">
+            <a:avLst/>
+          </a:prstGeom>
+          <a:solidFill>
+            <a:srgbClr val="1FBFAE"/>
+          </a:solidFill>
+          <a:ln>
+            <a:noFill/>
+          </a:ln>
+          <a:effectLst/>
+        </p:spPr>
+        <p:style>
+          <a:lnRef idx="1">
+            <a:schemeClr val="accent1"/>
+          </a:lnRef>
+          <a:fillRef idx="3">
+            <a:schemeClr val="accent1"/>
+          </a:fillRef>
+          <a:effectRef idx="2">
+            <a:schemeClr val="accent1"/>
+          </a:effectRef>
+          <a:fontRef idx="minor">
+            <a:schemeClr val="lt1"/>
+          </a:fontRef>
+        </p:style>
+        <p:txBody>
+          <a:bodyPr rtlCol="0" anchor="ctr"/>
+          <a:lstStyle/>
+          <a:p>
+            <a:pPr algn="ctr"/>
+          </a:p>
+        </p:txBody>
+      </p:sp>
+      <p:sp>
+        <p:nvSpPr>
+          <p:cNvPr id="37" name="TextBox 36"/>
+          <p:cNvSpPr txBox="1"/>
+          <p:nvPr/>
+        </p:nvSpPr>
+        <p:spPr>
+          <a:xfrm>
+            <a:off x="9532619" y="4270247"/>
+            <a:ext cx="925830" cy="365760"/>
+          </a:xfrm>
+          <a:prstGeom prst="rect">
+            <a:avLst/>
+          </a:prstGeom>
+          <a:noFill/>
+        </p:spPr>
+        <p:txBody>
+          <a:bodyPr wrap="square" anchor="ctr" lIns="27432" rIns="27432" tIns="27432" bIns="27432">
+            <a:spAutoFit/>
+          </a:bodyPr>
+          <a:lstStyle/>
+          <a:p>
+            <a:pPr algn="ctr"/>
+            <a:r>
+              <a:rPr sz="1000" b="1" i="0">
+                <a:solidFill>
+                  <a:srgbClr val="FFFFFF"/>
+                </a:solidFill>
+                <a:latin typeface="Calibri"/>
+              </a:rPr>
+              <a:t>2 wks</a:t>
+            </a:r>
+          </a:p>
+        </p:txBody>
+      </p:sp>
+      <p:sp>
+        <p:nvSpPr>
+          <p:cNvPr id="38" name="TextBox 37"/>
+          <p:cNvSpPr txBox="1"/>
+          <p:nvPr/>
+        </p:nvSpPr>
+        <p:spPr>
+          <a:xfrm>
+            <a:off x="749808" y="4800600"/>
+            <a:ext cx="3108960" cy="475488"/>
+          </a:xfrm>
+          <a:prstGeom prst="rect">
+            <a:avLst/>
+          </a:prstGeom>
+          <a:noFill/>
+        </p:spPr>
+        <p:txBody>
+          <a:bodyPr wrap="square" anchor="ctr" lIns="27432" rIns="27432" tIns="27432" bIns="27432">
+            <a:spAutoFit/>
+          </a:bodyPr>
+          <a:lstStyle/>
+          <a:p>
+            <a:pPr algn="l">
+              <a:spcAft>
+                <a:spcPts val="100"/>
+              </a:spcAft>
+            </a:pPr>
+            <a:r>
+              <a:rPr sz="1150" b="1" i="0">
+                <a:solidFill>
+                  <a:srgbClr val="0A1A33"/>
+                </a:solidFill>
+                <a:latin typeface="Calibri"/>
+              </a:rPr>
+              <a:t>Phase 6 · Documentation &amp; Finalise</a:t>
+            </a:r>
+          </a:p>
+          <a:p>
+            <a:pPr algn="l"/>
+            <a:r>
+              <a:rPr sz="900" b="0" i="0">
+                <a:solidFill>
+                  <a:srgbClr val="5B6B82"/>
+                </a:solidFill>
+                <a:latin typeface="Calibri"/>
+              </a:rPr>
+              <a:t>Report · final testing · submission</a:t>
+            </a:r>
+          </a:p>
+        </p:txBody>
+      </p:sp>
+      <p:sp>
+        <p:nvSpPr>
+          <p:cNvPr id="39" name="Rounded Rectangle 38"/>
+          <p:cNvSpPr/>
+          <p:nvPr/>
+        </p:nvSpPr>
+        <p:spPr>
+          <a:xfrm>
+            <a:off x="10458450" y="4855464"/>
+            <a:ext cx="925830" cy="365760"/>
+          </a:xfrm>
+          <a:prstGeom prst="roundRect">
+            <a:avLst/>
+          </a:prstGeom>
+          <a:solidFill>
+            <a:srgbClr val="0E7C72"/>
+          </a:solidFill>
+          <a:ln>
+            <a:noFill/>
+          </a:ln>
+          <a:effectLst/>
+        </p:spPr>
+        <p:style>
+          <a:lnRef idx="1">
+            <a:schemeClr val="accent1"/>
+          </a:lnRef>
+          <a:fillRef idx="3">
+            <a:schemeClr val="accent1"/>
+          </a:fillRef>
+          <a:effectRef idx="2">
+            <a:schemeClr val="accent1"/>
+          </a:effectRef>
+          <a:fontRef idx="minor">
+            <a:schemeClr val="lt1"/>
+          </a:fontRef>
+        </p:style>
+        <p:txBody>
+          <a:bodyPr rtlCol="0" anchor="ctr"/>
+          <a:lstStyle/>
+          <a:p>
+            <a:pPr algn="ctr"/>
+          </a:p>
+        </p:txBody>
+      </p:sp>
+      <p:sp>
+        <p:nvSpPr>
+          <p:cNvPr id="40" name="TextBox 39"/>
+          <p:cNvSpPr txBox="1"/>
+          <p:nvPr/>
+        </p:nvSpPr>
+        <p:spPr>
+          <a:xfrm>
+            <a:off x="10458450" y="4855464"/>
+            <a:ext cx="925830" cy="365760"/>
+          </a:xfrm>
+          <a:prstGeom prst="rect">
+            <a:avLst/>
+          </a:prstGeom>
+          <a:noFill/>
+        </p:spPr>
+        <p:txBody>
+          <a:bodyPr wrap="square" anchor="ctr" lIns="27432" rIns="27432" tIns="27432" bIns="27432">
+            <a:spAutoFit/>
+          </a:bodyPr>
+          <a:lstStyle/>
+          <a:p>
+            <a:pPr algn="ctr"/>
+            <a:r>
+              <a:rPr sz="1000" b="1" i="0">
+                <a:solidFill>
+                  <a:srgbClr val="FFFFFF"/>
+                </a:solidFill>
+                <a:latin typeface="Calibri"/>
+              </a:rPr>
+              <a:t>2 wks</a:t>
+            </a:r>
+          </a:p>
+        </p:txBody>
+      </p:sp>
+      <p:sp>
+        <p:nvSpPr>
+          <p:cNvPr id="41" name="Rounded Rectangle 40"/>
+          <p:cNvSpPr/>
+          <p:nvPr/>
+        </p:nvSpPr>
+        <p:spPr>
+          <a:xfrm>
+            <a:off x="749808" y="5431536"/>
+            <a:ext cx="2743200" cy="365760"/>
+          </a:xfrm>
+          <a:prstGeom prst="roundRect">
+            <a:avLst/>
+          </a:prstGeom>
+          <a:solidFill>
+            <a:srgbClr val="0A1A33"/>
+          </a:solidFill>
+          <a:ln>
+            <a:noFill/>
+          </a:ln>
+          <a:effectLst/>
+        </p:spPr>
+        <p:style>
+          <a:lnRef idx="1">
+            <a:schemeClr val="accent1"/>
+          </a:lnRef>
+          <a:fillRef idx="3">
+            <a:schemeClr val="accent1"/>
+          </a:fillRef>
+          <a:effectRef idx="2">
+            <a:schemeClr val="accent1"/>
+          </a:effectRef>
+          <a:fontRef idx="minor">
+            <a:schemeClr val="lt1"/>
+          </a:fontRef>
+        </p:style>
+        <p:txBody>
+          <a:bodyPr rtlCol="0" anchor="ctr"/>
+          <a:lstStyle/>
+          <a:p>
+            <a:pPr algn="ctr"/>
+          </a:p>
+        </p:txBody>
+      </p:sp>
+      <p:sp>
+        <p:nvSpPr>
+          <p:cNvPr id="42" name="TextBox 41"/>
+          <p:cNvSpPr txBox="1"/>
+          <p:nvPr/>
+        </p:nvSpPr>
+        <p:spPr>
+          <a:xfrm>
+            <a:off x="749808" y="5431536"/>
+            <a:ext cx="2743200" cy="365760"/>
+          </a:xfrm>
+          <a:prstGeom prst="rect">
+            <a:avLst/>
+          </a:prstGeom>
+          <a:noFill/>
+        </p:spPr>
+        <p:txBody>
+          <a:bodyPr wrap="square" anchor="ctr" lIns="27432" rIns="27432" tIns="27432" bIns="27432">
+            <a:spAutoFit/>
+          </a:bodyPr>
+          <a:lstStyle/>
+          <a:p>
+            <a:pPr algn="ctr"/>
+            <a:r>
+              <a:rPr sz="1100" b="1" i="0">
+                <a:solidFill>
+                  <a:srgbClr val="FFFFFF"/>
+                </a:solidFill>
+                <a:latin typeface="Calibri"/>
+              </a:rPr>
+              <a:t>TOTAL · 16 WEEKS</a:t>
+            </a:r>
+          </a:p>
+        </p:txBody>
+      </p:sp>
+      <p:sp>
+        <p:nvSpPr>
+          <p:cNvPr id="43" name="TextBox 42"/>
+          <p:cNvSpPr txBox="1"/>
+          <p:nvPr/>
+        </p:nvSpPr>
+        <p:spPr>
+          <a:xfrm>
+            <a:off x="3749039" y="5431536"/>
+            <a:ext cx="7680960" cy="411480"/>
+          </a:xfrm>
+          <a:prstGeom prst="rect">
+            <a:avLst/>
+          </a:prstGeom>
+          <a:noFill/>
+        </p:spPr>
+        <p:txBody>
+          <a:bodyPr wrap="square" anchor="ctr" lIns="27432" rIns="27432" tIns="27432" bIns="27432">
+            <a:spAutoFit/>
+          </a:bodyPr>
+          <a:lstStyle/>
+          <a:p>
+            <a:pPr algn="l"/>
+            <a:r>
+              <a:rPr sz="1100" b="1" i="0">
+                <a:solidFill>
+                  <a:srgbClr val="0E7C72"/>
+                </a:solidFill>
+                <a:latin typeface="Calibri"/>
+              </a:rPr>
+              <a:t>Critical path:  </a:t>
+            </a:r>
+            <a:r>
+              <a:rPr sz="1100" b="0" i="1">
+                <a:solidFill>
+                  <a:srgbClr val="16233B"/>
+                </a:solidFill>
+                <a:latin typeface="Calibri"/>
+              </a:rPr>
+              <a:t>model development → ensemble → evaluation. The web app is prototyped early, in parallel.</a:t>
+            </a:r>
           </a:p>
         </p:txBody>
       </p:sp>

</xml_diff>